<commit_message>
fix(ppt): restore navy section band, revert to Roboto, use deck colors
템플릿 초판이 세 군데 틀렸다.

1. 섹션 밴드가 사라졌다. 원본 밴드는 `202843` 으로 채운 텍스트박스 +
   흰 글자(28pt)인데, 배경 없는 투명 텍스트박스로 만들어서 덱 상단의
   남색 띠가 통째로 없어졌다. 원본에서 다시 만들었다.

2. 폰트를 Century Gothic 으로 바꿔놨던 걸 테마 원본값인 Roboto 로
   되돌렸다. 표지(1번 슬라이드)는 원본 Times New Roman / Arial Narrow
   서식을 그대로 두고 발표자 정보 텍스트만 갈아끼운다.

3. 그림이 테마 accent 팔레트를 쓰고 있었는데, 덱이 실제로 쓰는 색은
   `202843`(밴드·표 헤더) / `FF0000`(강조) / `0070C0`(제목) 셋뿐이었다.
   `_slide.py` SUBJECT 를 그 셋으로 교체하고 그림 4장을 다시 뽑았다.
   full-replay=빨강(제일 비싼 쪽), surgical=남색, parity=강조 파랑.

Co-Authored-By: Claude Opus 4.8 <noreply@anthropic.com>
Claude-Session: https://claude.ai/code/session_01FfKQPAstkv5E1GtvR5op9j
</commit_message>
<xml_diff>
--- a/ppt/template/radp-progress-template.pptx
+++ b/ppt/template/radp-progress-template.pptx
@@ -5125,14 +5125,14 @@
             </a:pPr>
             <a:r>
               <a:rPr lang="en-US" sz="1200" b="1">
-                <a:latin typeface="Century Gothic"/>
+                <a:latin typeface="Times New Roman"/>
                 <a:cs typeface="Times New Roman"/>
               </a:rPr>
               <a:t>Hakjae</a:t>
             </a:r>
             <a:r>
               <a:rPr lang="en-US" sz="1200" b="1">
-                <a:latin typeface="Century Gothic"/>
+                <a:latin typeface="Times New Roman"/>
                 <a:cs typeface="Times New Roman"/>
               </a:rPr>
               <a:t> Kim</a:t>
@@ -5148,14 +5148,14 @@
             </a:pPr>
             <a:r>
               <a:rPr lang="en-GB" sz="1200">
-                <a:latin typeface="Century Gothic"/>
+                <a:latin typeface="Times New Roman"/>
                 <a:cs typeface="Times New Roman"/>
               </a:rPr>
               <a:t>Department of </a:t>
             </a:r>
             <a:r>
               <a:rPr lang="en-GB" sz="1200">
-                <a:latin typeface="Century Gothic"/>
+                <a:latin typeface="Times New Roman"/>
                 <a:cs typeface="Times New Roman"/>
               </a:rPr>
               <a:t>Advanced Materials Science and Engineering</a:t>
@@ -5171,7 +5171,7 @@
             </a:pPr>
             <a:r>
               <a:rPr lang="en-GB" sz="1200">
-                <a:latin typeface="Century Gothic"/>
+                <a:latin typeface="Times New Roman"/>
                 <a:cs typeface="Times New Roman"/>
               </a:rPr>
               <a:t> </a:t>
@@ -5216,7 +5216,7 @@
             </a:pPr>
             <a:r>
               <a:rPr lang="en-GB" sz="1200">
-                <a:latin typeface="Century Gothic"/>
+                <a:latin typeface="Times New Roman"/>
                 <a:cs typeface="Times New Roman"/>
               </a:rPr>
               <a:t> Sungkyunkwan University </a:t>
@@ -5229,49 +5229,49 @@
             </a:pPr>
             <a:r>
               <a:rPr lang="en-GB" sz="1200">
-                <a:latin typeface="Century Gothic"/>
+                <a:latin typeface="Times New Roman"/>
                 <a:cs typeface="Times New Roman"/>
               </a:rPr>
               <a:t>2066, </a:t>
             </a:r>
             <a:r>
               <a:rPr lang="en-GB" sz="1200">
-                <a:latin typeface="Century Gothic"/>
+                <a:latin typeface="Times New Roman"/>
                 <a:cs typeface="Times New Roman"/>
               </a:rPr>
               <a:t>Seobu-ro</a:t>
             </a:r>
             <a:r>
               <a:rPr lang="en-GB" sz="1200">
-                <a:latin typeface="Century Gothic"/>
+                <a:latin typeface="Times New Roman"/>
                 <a:cs typeface="Times New Roman"/>
               </a:rPr>
               <a:t>, </a:t>
             </a:r>
             <a:r>
               <a:rPr lang="en-GB" sz="1200">
-                <a:latin typeface="Century Gothic"/>
+                <a:latin typeface="Times New Roman"/>
                 <a:cs typeface="Times New Roman"/>
               </a:rPr>
               <a:t>Jangan-gu</a:t>
             </a:r>
             <a:r>
               <a:rPr lang="en-GB" sz="1200">
-                <a:latin typeface="Century Gothic"/>
+                <a:latin typeface="Times New Roman"/>
                 <a:cs typeface="Times New Roman"/>
               </a:rPr>
               <a:t>, </a:t>
             </a:r>
             <a:r>
               <a:rPr lang="en-GB" sz="1200">
-                <a:latin typeface="Century Gothic"/>
+                <a:latin typeface="Times New Roman"/>
                 <a:cs typeface="Times New Roman"/>
               </a:rPr>
               <a:t>Suwon-si</a:t>
             </a:r>
             <a:r>
               <a:rPr lang="en-GB" sz="1200">
-                <a:latin typeface="Century Gothic"/>
+                <a:latin typeface="Times New Roman"/>
                 <a:cs typeface="Times New Roman"/>
               </a:rPr>
               <a:t>, Gyeonggi-do, Korea </a:t>
@@ -5284,21 +5284,21 @@
             </a:pPr>
             <a:r>
               <a:rPr lang="en-GB" sz="1200">
-                <a:latin typeface="Century Gothic"/>
+                <a:latin typeface="Times New Roman"/>
                 <a:cs typeface="Times New Roman"/>
               </a:rPr>
               <a:t> [e-mail: </a:t>
             </a:r>
             <a:r>
               <a:rPr lang="en-GB" sz="1200" b="1">
-                <a:latin typeface="Century Gothic"/>
+                <a:latin typeface="Times New Roman"/>
                 <a:cs typeface="Times New Roman"/>
               </a:rPr>
               <a:t>hjkim24</a:t>
             </a:r>
             <a:r>
               <a:rPr lang="en-GB" sz="1200">
-                <a:latin typeface="Century Gothic"/>
+                <a:latin typeface="Times New Roman"/>
                 <a:cs typeface="Times New Roman"/>
               </a:rPr>
               <a:t>@skku.edu] </a:t>
@@ -5354,7 +5354,7 @@
             </a:pPr>
             <a:r>
               <a:rPr lang="en-US" sz="3200">
-                <a:latin typeface="Century Gothic"/>
+                <a:latin typeface="Times New Roman"/>
                 <a:cs typeface="Times New Roman"/>
               </a:rPr>
               <a:t>Weekly meeting</a:t>
@@ -5393,7 +5393,7 @@
             </a:pPr>
             <a:r>
               <a:rPr lang="en-US">
-                <a:latin typeface="Century Gothic"/>
+                <a:latin typeface="Arial Narrow"/>
               </a:rPr>
               <a:t>RESEARCH PROGRESS</a:t>
             </a:r>
@@ -5501,9 +5501,7 @@
               <a:defRPr/>
             </a:pPr>
             <a:r>
-              <a:rPr lang="en-GB">
-                <a:latin typeface="Century Gothic"/>
-              </a:rPr>
+              <a:rPr lang="en-GB"/>
               <a:t>Sections</a:t>
             </a:r>
             <a:endParaRPr/>
@@ -5542,7 +5540,7 @@
                 <a:solidFill>
                   <a:srgbClr val="404040"/>
                 </a:solidFill>
-                <a:latin typeface="Century Gothic"/>
+                <a:latin typeface="Roboto"/>
               </a:rPr>
               <a:t>1. Summary of last meeting/progress</a:t>
             </a:r>
@@ -5554,7 +5552,7 @@
                 <a:solidFill>
                   <a:srgbClr val="404040"/>
                 </a:solidFill>
-                <a:latin typeface="Century Gothic"/>
+                <a:latin typeface="Roboto"/>
               </a:rPr>
               <a:t>2. Progress last week</a:t>
             </a:r>
@@ -5565,7 +5563,7 @@
                 <a:solidFill>
                   <a:srgbClr val="404040"/>
                 </a:solidFill>
-                <a:latin typeface="Century Gothic"/>
+                <a:latin typeface="Roboto"/>
               </a:rPr>
               <a:t>3. Plan for next 1 week</a:t>
             </a:r>
@@ -5576,7 +5574,7 @@
                 <a:solidFill>
                   <a:srgbClr val="404040"/>
                 </a:solidFill>
-                <a:latin typeface="Century Gothic"/>
+                <a:latin typeface="Roboto"/>
               </a:rPr>
               <a:t>4. Reference</a:t>
             </a:r>
@@ -5671,21 +5669,25 @@
           <a:prstGeom prst="rect">
             <a:avLst/>
           </a:prstGeom>
-          <a:noFill/>
+          <a:solidFill>
+            <a:srgbClr val="202843"/>
+          </a:solidFill>
+          <a:ln>
+            <a:noFill/>
+          </a:ln>
         </p:spPr>
         <p:txBody>
-          <a:bodyPr wrap="square">
+          <a:bodyPr wrap="none" lIns="164592" tIns="18288">
             <a:spAutoFit/>
           </a:bodyPr>
           <a:lstStyle/>
           <a:p>
-            <a:pPr algn="l"/>
-            <a:r>
-              <a:rPr sz="2800" b="0">
+            <a:r>
+              <a:rPr sz="2800">
                 <a:solidFill>
-                  <a:srgbClr val="404040"/>
+                  <a:srgbClr val="FFFFFF"/>
                 </a:solidFill>
-                <a:latin typeface="Century Gothic"/>
+                <a:latin typeface="Roboto"/>
               </a:rPr>
               <a:t>1. Summary of last meeting/progress</a:t>
             </a:r>
@@ -5720,51 +5722,16 @@
                 <a:solidFill>
                   <a:srgbClr val="404040"/>
                 </a:solidFill>
-                <a:latin typeface="Century Gothic"/>
+                <a:latin typeface="Roboto"/>
               </a:rPr>
               <a:t>지난 미팅 피드백과 이번 주 대응</a:t>
             </a:r>
           </a:p>
         </p:txBody>
       </p:sp>
-      <p:sp>
-        <p:nvSpPr>
-          <p:cNvPr id="4" name="TextBox 3"/>
-          <p:cNvSpPr txBox="1"/>
-          <p:nvPr/>
-        </p:nvSpPr>
-        <p:spPr>
-          <a:xfrm>
-            <a:off x="10213848" y="6601968"/>
-            <a:ext cx="640080" cy="237744"/>
-          </a:xfrm>
-          <a:prstGeom prst="rect">
-            <a:avLst/>
-          </a:prstGeom>
-          <a:noFill/>
-        </p:spPr>
-        <p:txBody>
-          <a:bodyPr wrap="square">
-            <a:spAutoFit/>
-          </a:bodyPr>
-          <a:lstStyle/>
-          <a:p>
-            <a:pPr algn="l"/>
-            <a:r>
-              <a:rPr sz="1200" b="0">
-                <a:solidFill>
-                  <a:srgbClr val="404040"/>
-                </a:solidFill>
-                <a:latin typeface="Century Gothic"/>
-              </a:rPr>
-              <a:t>3</a:t>
-            </a:r>
-          </a:p>
-        </p:txBody>
-      </p:sp>
       <p:graphicFrame>
         <p:nvGraphicFramePr>
-          <p:cNvPr id="5" name="Table 4"/>
+          <p:cNvPr id="4" name="Table 3"/>
           <p:cNvGraphicFramePr>
             <a:graphicFrameLocks noGrp="1"/>
           </p:cNvGraphicFramePr>
@@ -5772,7 +5739,7 @@
         </p:nvGraphicFramePr>
         <p:xfrm>
           <a:off x="576072" y="1600200"/>
-          <a:ext cx="11018520" cy="2926080"/>
+          <a:ext cx="11018520" cy="2743200"/>
         </p:xfrm>
         <a:graphic>
           <a:graphicData uri="http://schemas.openxmlformats.org/drawingml/2006/table">
@@ -5784,7 +5751,7 @@
                 <a:gridCol w="4937760"/>
                 <a:gridCol w="6080760"/>
               </a:tblGrid>
-              <a:tr h="731520">
+              <a:tr h="685800">
                 <a:tc>
                   <a:txBody>
                     <a:bodyPr/>
@@ -5793,15 +5760,19 @@
                       <a:r>
                         <a:rPr sz="1600" b="1">
                           <a:solidFill>
-                            <a:srgbClr val="404040"/>
+                            <a:srgbClr val="FFFFFF"/>
                           </a:solidFill>
-                          <a:latin typeface="Century Gothic"/>
+                          <a:latin typeface="Roboto"/>
                         </a:rPr>
                         <a:t>피드백</a:t>
                       </a:r>
                     </a:p>
                   </a:txBody>
-                  <a:tcPr/>
+                  <a:tcPr>
+                    <a:solidFill>
+                      <a:srgbClr val="202843"/>
+                    </a:solidFill>
+                  </a:tcPr>
                 </a:tc>
                 <a:tc>
                   <a:txBody>
@@ -5811,18 +5782,22 @@
                       <a:r>
                         <a:rPr sz="1600" b="1">
                           <a:solidFill>
-                            <a:srgbClr val="404040"/>
+                            <a:srgbClr val="FFFFFF"/>
                           </a:solidFill>
-                          <a:latin typeface="Century Gothic"/>
+                          <a:latin typeface="Roboto"/>
                         </a:rPr>
                         <a:t>이번 주 대응</a:t>
                       </a:r>
                     </a:p>
                   </a:txBody>
-                  <a:tcPr/>
+                  <a:tcPr>
+                    <a:solidFill>
+                      <a:srgbClr val="202843"/>
+                    </a:solidFill>
+                  </a:tcPr>
                 </a:tc>
               </a:tr>
-              <a:tr h="731520">
+              <a:tr h="685800">
                 <a:tc>
                   <a:txBody>
                     <a:bodyPr/>
@@ -5833,9 +5808,9 @@
                           <a:solidFill>
                             <a:srgbClr val="404040"/>
                           </a:solidFill>
-                          <a:latin typeface="Century Gothic"/>
+                          <a:latin typeface="Roboto"/>
                         </a:rPr>
-                        <a:t>피드백 요지 한 줄</a:t>
+                        <a:t>요지 한 줄</a:t>
                       </a:r>
                     </a:p>
                   </a:txBody>
@@ -5851,16 +5826,16 @@
                           <a:solidFill>
                             <a:srgbClr val="404040"/>
                           </a:solidFill>
-                          <a:latin typeface="Century Gothic"/>
+                          <a:latin typeface="Roboto"/>
                         </a:rPr>
-                        <a:t>무엇을 바꿨는지 한 줄</a:t>
+                        <a:t>무엇을 바꿨는지</a:t>
                       </a:r>
                     </a:p>
                   </a:txBody>
                   <a:tcPr/>
                 </a:tc>
               </a:tr>
-              <a:tr h="731520">
+              <a:tr h="685800">
                 <a:tc>
                   <a:txBody>
                     <a:bodyPr/>
@@ -5871,9 +5846,9 @@
                           <a:solidFill>
                             <a:srgbClr val="404040"/>
                           </a:solidFill>
-                          <a:latin typeface="Century Gothic"/>
+                          <a:latin typeface="Roboto"/>
                         </a:rPr>
-                        <a:t>피드백 요지 한 줄</a:t>
+                        <a:t>요지 한 줄</a:t>
                       </a:r>
                     </a:p>
                   </a:txBody>
@@ -5889,16 +5864,16 @@
                           <a:solidFill>
                             <a:srgbClr val="404040"/>
                           </a:solidFill>
-                          <a:latin typeface="Century Gothic"/>
+                          <a:latin typeface="Roboto"/>
                         </a:rPr>
-                        <a:t>무엇을 바꿨는지 한 줄</a:t>
+                        <a:t>무엇을 바꿨는지</a:t>
                       </a:r>
                     </a:p>
                   </a:txBody>
                   <a:tcPr/>
                 </a:tc>
               </a:tr>
-              <a:tr h="731520">
+              <a:tr h="685800">
                 <a:tc>
                   <a:txBody>
                     <a:bodyPr/>
@@ -5909,9 +5884,9 @@
                           <a:solidFill>
                             <a:srgbClr val="404040"/>
                           </a:solidFill>
-                          <a:latin typeface="Century Gothic"/>
+                          <a:latin typeface="Roboto"/>
                         </a:rPr>
-                        <a:t>피드백 요지 한 줄</a:t>
+                        <a:t>요지 한 줄</a:t>
                       </a:r>
                     </a:p>
                   </a:txBody>
@@ -5927,9 +5902,9 @@
                           <a:solidFill>
                             <a:srgbClr val="404040"/>
                           </a:solidFill>
-                          <a:latin typeface="Century Gothic"/>
+                          <a:latin typeface="Roboto"/>
                         </a:rPr>
-                        <a:t>무엇을 바꿨는지 한 줄</a:t>
+                        <a:t>무엇을 바꿨는지</a:t>
                       </a:r>
                     </a:p>
                   </a:txBody>
@@ -5972,21 +5947,25 @@
           <a:prstGeom prst="rect">
             <a:avLst/>
           </a:prstGeom>
-          <a:noFill/>
+          <a:solidFill>
+            <a:srgbClr val="202843"/>
+          </a:solidFill>
+          <a:ln>
+            <a:noFill/>
+          </a:ln>
         </p:spPr>
         <p:txBody>
-          <a:bodyPr wrap="square">
+          <a:bodyPr wrap="none" lIns="164592" tIns="18288">
             <a:spAutoFit/>
           </a:bodyPr>
           <a:lstStyle/>
           <a:p>
-            <a:pPr algn="l"/>
-            <a:r>
-              <a:rPr sz="2800" b="0">
+            <a:r>
+              <a:rPr sz="2800">
                 <a:solidFill>
-                  <a:srgbClr val="404040"/>
+                  <a:srgbClr val="FFFFFF"/>
                 </a:solidFill>
-                <a:latin typeface="Century Gothic"/>
+                <a:latin typeface="Roboto"/>
               </a:rPr>
               <a:t>2. Progress last week</a:t>
             </a:r>
@@ -6021,7 +6000,7 @@
                 <a:solidFill>
                   <a:srgbClr val="0070C0"/>
                 </a:solidFill>
-                <a:latin typeface="Century Gothic"/>
+                <a:latin typeface="Roboto"/>
               </a:rPr>
               <a:t>1. RADP</a:t>
             </a:r>
@@ -6056,9 +6035,9 @@
                 <a:solidFill>
                   <a:srgbClr val="404040"/>
                 </a:solidFill>
-                <a:latin typeface="Century Gothic"/>
+                <a:latin typeface="Roboto"/>
               </a:rPr>
-              <a:t>a. 복구 3계열 TTR(P) 실측</a:t>
+              <a:t>a. 소제목 한 줄</a:t>
             </a:r>
           </a:p>
         </p:txBody>
@@ -6066,41 +6045,6 @@
       <p:sp>
         <p:nvSpPr>
           <p:cNvPr id="5" name="TextBox 4"/>
-          <p:cNvSpPr txBox="1"/>
-          <p:nvPr/>
-        </p:nvSpPr>
-        <p:spPr>
-          <a:xfrm>
-            <a:off x="10213848" y="6601968"/>
-            <a:ext cx="640080" cy="237744"/>
-          </a:xfrm>
-          <a:prstGeom prst="rect">
-            <a:avLst/>
-          </a:prstGeom>
-          <a:noFill/>
-        </p:spPr>
-        <p:txBody>
-          <a:bodyPr wrap="square">
-            <a:spAutoFit/>
-          </a:bodyPr>
-          <a:lstStyle/>
-          <a:p>
-            <a:pPr algn="l"/>
-            <a:r>
-              <a:rPr sz="1200" b="0">
-                <a:solidFill>
-                  <a:srgbClr val="404040"/>
-                </a:solidFill>
-                <a:latin typeface="Century Gothic"/>
-              </a:rPr>
-              <a:t>4</a:t>
-            </a:r>
-          </a:p>
-        </p:txBody>
-      </p:sp>
-      <p:sp>
-        <p:nvSpPr>
-          <p:cNvPr id="6" name="TextBox 5"/>
           <p:cNvSpPr txBox="1"/>
           <p:nvPr/>
         </p:nvSpPr>
@@ -6122,42 +6066,91 @@
           <a:p>
             <a:pPr algn="l"/>
             <a:r>
-              <a:rPr sz="1600">
+              <a:rPr sz="1600" b="0">
                 <a:solidFill>
                   <a:srgbClr val="404040"/>
                 </a:solidFill>
-                <a:latin typeface="Century Gothic"/>
+                <a:latin typeface="Roboto"/>
               </a:rPr>
-              <a:t>• 세 계열 같은 조건 비교</a:t>
-            </a:r>
-          </a:p>
-          <a:p>
-            <a:r>
-              <a:rPr sz="1600">
+              <a:t>• 라벨 한 줄</a:t>
+            </a:r>
+          </a:p>
+          <a:p>
+            <a:pPr algn="l"/>
+            <a:r>
+              <a:rPr sz="1600" b="0">
                 <a:solidFill>
                   <a:srgbClr val="404040"/>
                 </a:solidFill>
-                <a:latin typeface="Century Gothic"/>
+                <a:latin typeface="Roboto"/>
               </a:rPr>
-              <a:t>• parity 기울기 0.87 ms/pos</a:t>
-            </a:r>
-          </a:p>
-          <a:p>
-            <a:r>
-              <a:rPr sz="1600">
+              <a:t>• 라벨 한 줄</a:t>
+            </a:r>
+          </a:p>
+          <a:p>
+            <a:pPr algn="l"/>
+            <a:r>
+              <a:rPr sz="1600" b="0">
                 <a:solidFill>
                   <a:srgbClr val="404040"/>
                 </a:solidFill>
-                <a:latin typeface="Century Gothic"/>
+                <a:latin typeface="Roboto"/>
               </a:rPr>
-              <a:t>• 깊이 8배, 복구시간 +6%</a:t>
-            </a:r>
-          </a:p>
-        </p:txBody>
-      </p:sp>
-      <p:sp>
-        <p:nvSpPr>
-          <p:cNvPr id="8" name="TextBox 7"/>
+              <a:t>• 숫자 한 방</a:t>
+            </a:r>
+          </a:p>
+        </p:txBody>
+      </p:sp>
+      <p:sp>
+        <p:nvSpPr>
+          <p:cNvPr id="6" name="TextBox 5"/>
+          <p:cNvSpPr txBox="1"/>
+          <p:nvPr/>
+        </p:nvSpPr>
+        <p:spPr>
+          <a:xfrm>
+            <a:off x="4846320" y="1600200"/>
+            <a:ext cx="6766560" cy="4069080"/>
+          </a:xfrm>
+          <a:prstGeom prst="rect">
+            <a:avLst/>
+          </a:prstGeom>
+          <a:noFill/>
+        </p:spPr>
+        <p:txBody>
+          <a:bodyPr wrap="square">
+            <a:spAutoFit/>
+          </a:bodyPr>
+          <a:lstStyle/>
+          <a:p>
+            <a:pPr algn="ctr"/>
+            <a:r>
+              <a:rPr sz="1600" b="0">
+                <a:solidFill>
+                  <a:srgbClr val="0070C0"/>
+                </a:solidFill>
+                <a:latin typeface="Roboto"/>
+              </a:rPr>
+              <a:t>[ 시각물 영역 ]</a:t>
+            </a:r>
+          </a:p>
+          <a:p>
+            <a:pPr algn="ctr"/>
+            <a:r>
+              <a:rPr sz="1600" b="0">
+                <a:solidFill>
+                  <a:srgbClr val="0070C0"/>
+                </a:solidFill>
+                <a:latin typeface="Roboto"/>
+              </a:rPr>
+              <a:t>7.4 × 4.45 in</a:t>
+            </a:r>
+          </a:p>
+        </p:txBody>
+      </p:sp>
+      <p:sp>
+        <p:nvSpPr>
+          <p:cNvPr id="7" name="TextBox 6"/>
           <p:cNvSpPr txBox="1"/>
           <p:nvPr/>
         </p:nvSpPr>
@@ -6179,41 +6172,17 @@
           <a:p>
             <a:pPr algn="l"/>
             <a:r>
-              <a:rPr sz="1200">
+              <a:rPr sz="1200" b="0">
                 <a:solidFill>
                   <a:srgbClr val="404040"/>
                 </a:solidFill>
-                <a:latin typeface="Century Gothic"/>
+                <a:latin typeface="Roboto"/>
               </a:rPr>
-              <a:t>OPT-350M 24층 / 5-stage 이종 체인 / 15개 트라이얼 전부 유효</a:t>
-            </a:r>
-          </a:p>
-        </p:txBody>
-      </p:sp>
-      <p:pic>
-        <p:nvPicPr>
-          <p:cNvPr id="9" name="Picture 8" descr="fig_recovery_ttr_slide.png"/>
-          <p:cNvPicPr>
-            <a:picLocks noChangeAspect="1"/>
-          </p:cNvPicPr>
-          <p:nvPr/>
-        </p:nvPicPr>
-        <p:blipFill>
-          <a:blip r:embed="rId2"/>
-          <a:stretch>
-            <a:fillRect/>
-          </a:stretch>
-        </p:blipFill>
-        <p:spPr>
-          <a:xfrm>
-            <a:off x="4846320" y="1600200"/>
-            <a:ext cx="6766560" cy="4065057"/>
-          </a:xfrm>
-          <a:prstGeom prst="rect">
-            <a:avLst/>
-          </a:prstGeom>
-        </p:spPr>
-      </p:pic>
+              <a:t>캡션: 환경 / 조건 / 유효 샘플 수</a:t>
+            </a:r>
+          </a:p>
+        </p:txBody>
+      </p:sp>
     </p:spTree>
   </p:cSld>
   <p:clrMapOvr>
@@ -6246,21 +6215,25 @@
           <a:prstGeom prst="rect">
             <a:avLst/>
           </a:prstGeom>
-          <a:noFill/>
+          <a:solidFill>
+            <a:srgbClr val="202843"/>
+          </a:solidFill>
+          <a:ln>
+            <a:noFill/>
+          </a:ln>
         </p:spPr>
         <p:txBody>
-          <a:bodyPr wrap="square">
+          <a:bodyPr wrap="none" lIns="164592" tIns="18288">
             <a:spAutoFit/>
           </a:bodyPr>
           <a:lstStyle/>
           <a:p>
-            <a:pPr algn="l"/>
-            <a:r>
-              <a:rPr sz="2800" b="0">
+            <a:r>
+              <a:rPr sz="2800">
                 <a:solidFill>
-                  <a:srgbClr val="404040"/>
+                  <a:srgbClr val="FFFFFF"/>
                 </a:solidFill>
-                <a:latin typeface="Century Gothic"/>
+                <a:latin typeface="Roboto"/>
               </a:rPr>
               <a:t>2. Progress last week</a:t>
             </a:r>
@@ -6295,7 +6268,7 @@
                 <a:solidFill>
                   <a:srgbClr val="0070C0"/>
                 </a:solidFill>
-                <a:latin typeface="Century Gothic"/>
+                <a:latin typeface="Roboto"/>
               </a:rPr>
               <a:t>1. RADP</a:t>
             </a:r>
@@ -6330,9 +6303,9 @@
                 <a:solidFill>
                   <a:srgbClr val="404040"/>
                 </a:solidFill>
-                <a:latin typeface="Century Gothic"/>
+                <a:latin typeface="Roboto"/>
               </a:rPr>
-              <a:t>b. 좌우 비교가 필요할 때</a:t>
+              <a:t>b. 좌우 비교</a:t>
             </a:r>
           </a:p>
         </p:txBody>
@@ -6340,41 +6313,6 @@
       <p:sp>
         <p:nvSpPr>
           <p:cNvPr id="5" name="TextBox 4"/>
-          <p:cNvSpPr txBox="1"/>
-          <p:nvPr/>
-        </p:nvSpPr>
-        <p:spPr>
-          <a:xfrm>
-            <a:off x="10213848" y="6601968"/>
-            <a:ext cx="640080" cy="237744"/>
-          </a:xfrm>
-          <a:prstGeom prst="rect">
-            <a:avLst/>
-          </a:prstGeom>
-          <a:noFill/>
-        </p:spPr>
-        <p:txBody>
-          <a:bodyPr wrap="square">
-            <a:spAutoFit/>
-          </a:bodyPr>
-          <a:lstStyle/>
-          <a:p>
-            <a:pPr algn="l"/>
-            <a:r>
-              <a:rPr sz="1200" b="0">
-                <a:solidFill>
-                  <a:srgbClr val="404040"/>
-                </a:solidFill>
-                <a:latin typeface="Century Gothic"/>
-              </a:rPr>
-              <a:t>5</a:t>
-            </a:r>
-          </a:p>
-        </p:txBody>
-      </p:sp>
-      <p:sp>
-        <p:nvSpPr>
-          <p:cNvPr id="6" name="TextBox 5"/>
           <p:cNvSpPr txBox="1"/>
           <p:nvPr/>
         </p:nvSpPr>
@@ -6400,7 +6338,7 @@
                 <a:solidFill>
                   <a:srgbClr val="0070C0"/>
                 </a:solidFill>
-                <a:latin typeface="Century Gothic"/>
+                <a:latin typeface="Roboto"/>
               </a:rPr>
               <a:t>[ 좌측 시각물 ]</a:t>
             </a:r>
@@ -6409,7 +6347,7 @@
       </p:sp>
       <p:sp>
         <p:nvSpPr>
-          <p:cNvPr id="7" name="TextBox 6"/>
+          <p:cNvPr id="6" name="TextBox 5"/>
           <p:cNvSpPr txBox="1"/>
           <p:nvPr/>
         </p:nvSpPr>
@@ -6435,7 +6373,7 @@
                 <a:solidFill>
                   <a:srgbClr val="0070C0"/>
                 </a:solidFill>
-                <a:latin typeface="Century Gothic"/>
+                <a:latin typeface="Roboto"/>
               </a:rPr>
               <a:t>[ 우측 시각물 ]</a:t>
             </a:r>
@@ -6444,13 +6382,13 @@
       </p:sp>
       <p:sp>
         <p:nvSpPr>
-          <p:cNvPr id="8" name="TextBox 7"/>
+          <p:cNvPr id="7" name="TextBox 6"/>
           <p:cNvSpPr txBox="1"/>
           <p:nvPr/>
         </p:nvSpPr>
         <p:spPr>
           <a:xfrm>
-            <a:off x="576072" y="5760720"/>
+            <a:off x="576072" y="5806440"/>
             <a:ext cx="11018520" cy="365760"/>
           </a:xfrm>
           <a:prstGeom prst="rect">
@@ -6470,9 +6408,9 @@
                 <a:solidFill>
                   <a:srgbClr val="404040"/>
                 </a:solidFill>
-                <a:latin typeface="Century Gothic"/>
+                <a:latin typeface="Roboto"/>
               </a:rPr>
-              <a:t>• 두 그림에서 읽어야 할 것 한 줄</a:t>
+              <a:t>• 두 그림에서 읽어야 할 것</a:t>
             </a:r>
           </a:p>
         </p:txBody>
@@ -6509,21 +6447,25 @@
           <a:prstGeom prst="rect">
             <a:avLst/>
           </a:prstGeom>
-          <a:noFill/>
+          <a:solidFill>
+            <a:srgbClr val="202843"/>
+          </a:solidFill>
+          <a:ln>
+            <a:noFill/>
+          </a:ln>
         </p:spPr>
         <p:txBody>
-          <a:bodyPr wrap="square">
+          <a:bodyPr wrap="none" lIns="164592" tIns="18288">
             <a:spAutoFit/>
           </a:bodyPr>
           <a:lstStyle/>
           <a:p>
-            <a:pPr algn="l"/>
-            <a:r>
-              <a:rPr sz="2800" b="0">
+            <a:r>
+              <a:rPr sz="2800">
                 <a:solidFill>
-                  <a:srgbClr val="404040"/>
+                  <a:srgbClr val="FFFFFF"/>
                 </a:solidFill>
-                <a:latin typeface="Century Gothic"/>
+                <a:latin typeface="Roboto"/>
               </a:rPr>
               <a:t>2. Progress last week</a:t>
             </a:r>
@@ -6558,7 +6500,7 @@
                 <a:solidFill>
                   <a:srgbClr val="0070C0"/>
                 </a:solidFill>
-                <a:latin typeface="Century Gothic"/>
+                <a:latin typeface="Roboto"/>
               </a:rPr>
               <a:t>2. Measurement</a:t>
             </a:r>
@@ -6593,51 +6535,16 @@
                 <a:solidFill>
                   <a:srgbClr val="404040"/>
                 </a:solidFill>
-                <a:latin typeface="Century Gothic"/>
+                <a:latin typeface="Roboto"/>
               </a:rPr>
               <a:t>c. 수치 보고</a:t>
             </a:r>
           </a:p>
         </p:txBody>
       </p:sp>
-      <p:sp>
-        <p:nvSpPr>
-          <p:cNvPr id="5" name="TextBox 4"/>
-          <p:cNvSpPr txBox="1"/>
-          <p:nvPr/>
-        </p:nvSpPr>
-        <p:spPr>
-          <a:xfrm>
-            <a:off x="10213848" y="6601968"/>
-            <a:ext cx="640080" cy="237744"/>
-          </a:xfrm>
-          <a:prstGeom prst="rect">
-            <a:avLst/>
-          </a:prstGeom>
-          <a:noFill/>
-        </p:spPr>
-        <p:txBody>
-          <a:bodyPr wrap="square">
-            <a:spAutoFit/>
-          </a:bodyPr>
-          <a:lstStyle/>
-          <a:p>
-            <a:pPr algn="l"/>
-            <a:r>
-              <a:rPr sz="1200" b="0">
-                <a:solidFill>
-                  <a:srgbClr val="404040"/>
-                </a:solidFill>
-                <a:latin typeface="Century Gothic"/>
-              </a:rPr>
-              <a:t>6</a:t>
-            </a:r>
-          </a:p>
-        </p:txBody>
-      </p:sp>
       <p:graphicFrame>
         <p:nvGraphicFramePr>
-          <p:cNvPr id="6" name="Table 5"/>
+          <p:cNvPr id="5" name="Table 4"/>
           <p:cNvGraphicFramePr>
             <a:graphicFrameLocks noGrp="1"/>
           </p:cNvGraphicFramePr>
@@ -6667,15 +6574,19 @@
                       <a:r>
                         <a:rPr sz="1600" b="1">
                           <a:solidFill>
-                            <a:srgbClr val="404040"/>
+                            <a:srgbClr val="FFFFFF"/>
                           </a:solidFill>
-                          <a:latin typeface="Century Gothic"/>
+                          <a:latin typeface="Roboto"/>
                         </a:rPr>
                         <a:t>구분</a:t>
                       </a:r>
                     </a:p>
                   </a:txBody>
-                  <a:tcPr/>
+                  <a:tcPr>
+                    <a:solidFill>
+                      <a:srgbClr val="202843"/>
+                    </a:solidFill>
+                  </a:tcPr>
                 </a:tc>
                 <a:tc>
                   <a:txBody>
@@ -6685,15 +6596,19 @@
                       <a:r>
                         <a:rPr sz="1600" b="1">
                           <a:solidFill>
-                            <a:srgbClr val="404040"/>
+                            <a:srgbClr val="FFFFFF"/>
                           </a:solidFill>
-                          <a:latin typeface="Century Gothic"/>
+                          <a:latin typeface="Roboto"/>
                         </a:rPr>
                         <a:t>하는 일</a:t>
                       </a:r>
                     </a:p>
                   </a:txBody>
-                  <a:tcPr/>
+                  <a:tcPr>
+                    <a:solidFill>
+                      <a:srgbClr val="202843"/>
+                    </a:solidFill>
+                  </a:tcPr>
                 </a:tc>
                 <a:tc>
                   <a:txBody>
@@ -6703,15 +6618,19 @@
                       <a:r>
                         <a:rPr sz="1600" b="1">
                           <a:solidFill>
-                            <a:srgbClr val="404040"/>
+                            <a:srgbClr val="FFFFFF"/>
                           </a:solidFill>
-                          <a:latin typeface="Century Gothic"/>
+                          <a:latin typeface="Roboto"/>
                         </a:rPr>
                         <a:t>비용</a:t>
                       </a:r>
                     </a:p>
                   </a:txBody>
-                  <a:tcPr/>
+                  <a:tcPr>
+                    <a:solidFill>
+                      <a:srgbClr val="202843"/>
+                    </a:solidFill>
+                  </a:tcPr>
                 </a:tc>
               </a:tr>
               <a:tr h="594360">
@@ -6725,7 +6644,7 @@
                           <a:solidFill>
                             <a:srgbClr val="404040"/>
                           </a:solidFill>
-                          <a:latin typeface="Century Gothic"/>
+                          <a:latin typeface="Roboto"/>
                         </a:rPr>
                         <a:t>—</a:t>
                       </a:r>
@@ -6743,7 +6662,7 @@
                           <a:solidFill>
                             <a:srgbClr val="404040"/>
                           </a:solidFill>
-                          <a:latin typeface="Century Gothic"/>
+                          <a:latin typeface="Roboto"/>
                         </a:rPr>
                         <a:t>—</a:t>
                       </a:r>
@@ -6761,7 +6680,7 @@
                           <a:solidFill>
                             <a:srgbClr val="404040"/>
                           </a:solidFill>
-                          <a:latin typeface="Century Gothic"/>
+                          <a:latin typeface="Roboto"/>
                         </a:rPr>
                         <a:t>—</a:t>
                       </a:r>
@@ -6781,7 +6700,7 @@
                           <a:solidFill>
                             <a:srgbClr val="404040"/>
                           </a:solidFill>
-                          <a:latin typeface="Century Gothic"/>
+                          <a:latin typeface="Roboto"/>
                         </a:rPr>
                         <a:t>—</a:t>
                       </a:r>
@@ -6799,7 +6718,7 @@
                           <a:solidFill>
                             <a:srgbClr val="404040"/>
                           </a:solidFill>
-                          <a:latin typeface="Century Gothic"/>
+                          <a:latin typeface="Roboto"/>
                         </a:rPr>
                         <a:t>—</a:t>
                       </a:r>
@@ -6817,7 +6736,7 @@
                           <a:solidFill>
                             <a:srgbClr val="404040"/>
                           </a:solidFill>
-                          <a:latin typeface="Century Gothic"/>
+                          <a:latin typeface="Roboto"/>
                         </a:rPr>
                         <a:t>—</a:t>
                       </a:r>
@@ -6837,7 +6756,7 @@
                           <a:solidFill>
                             <a:srgbClr val="404040"/>
                           </a:solidFill>
-                          <a:latin typeface="Century Gothic"/>
+                          <a:latin typeface="Roboto"/>
                         </a:rPr>
                         <a:t>—</a:t>
                       </a:r>
@@ -6855,7 +6774,7 @@
                           <a:solidFill>
                             <a:srgbClr val="404040"/>
                           </a:solidFill>
-                          <a:latin typeface="Century Gothic"/>
+                          <a:latin typeface="Roboto"/>
                         </a:rPr>
                         <a:t>—</a:t>
                       </a:r>
@@ -6873,7 +6792,7 @@
                           <a:solidFill>
                             <a:srgbClr val="404040"/>
                           </a:solidFill>
-                          <a:latin typeface="Century Gothic"/>
+                          <a:latin typeface="Roboto"/>
                         </a:rPr>
                         <a:t>—</a:t>
                       </a:r>
@@ -6888,13 +6807,13 @@
       </p:graphicFrame>
       <p:sp>
         <p:nvSpPr>
-          <p:cNvPr id="7" name="TextBox 6"/>
+          <p:cNvPr id="6" name="TextBox 5"/>
           <p:cNvSpPr txBox="1"/>
           <p:nvPr/>
         </p:nvSpPr>
         <p:spPr>
           <a:xfrm>
-            <a:off x="576072" y="4206240"/>
+            <a:off x="576072" y="4251960"/>
             <a:ext cx="11018520" cy="365760"/>
           </a:xfrm>
           <a:prstGeom prst="rect">
@@ -6914,9 +6833,9 @@
                 <a:solidFill>
                   <a:srgbClr val="404040"/>
                 </a:solidFill>
-                <a:latin typeface="Century Gothic"/>
+                <a:latin typeface="Roboto"/>
               </a:rPr>
-              <a:t>• 표에서 읽어야 할 결론 한 줄</a:t>
+              <a:t>• 표에서 읽어야 할 결론</a:t>
             </a:r>
           </a:p>
         </p:txBody>
@@ -6953,21 +6872,25 @@
           <a:prstGeom prst="rect">
             <a:avLst/>
           </a:prstGeom>
-          <a:noFill/>
+          <a:solidFill>
+            <a:srgbClr val="202843"/>
+          </a:solidFill>
+          <a:ln>
+            <a:noFill/>
+          </a:ln>
         </p:spPr>
         <p:txBody>
-          <a:bodyPr wrap="square">
+          <a:bodyPr wrap="none" lIns="164592" tIns="18288">
             <a:spAutoFit/>
           </a:bodyPr>
           <a:lstStyle/>
           <a:p>
-            <a:pPr algn="l"/>
-            <a:r>
-              <a:rPr sz="2800" b="0">
+            <a:r>
+              <a:rPr sz="2800">
                 <a:solidFill>
-                  <a:srgbClr val="404040"/>
+                  <a:srgbClr val="FFFFFF"/>
                 </a:solidFill>
-                <a:latin typeface="Century Gothic"/>
+                <a:latin typeface="Roboto"/>
               </a:rPr>
               <a:t>3. Plan for next 1 week</a:t>
             </a:r>
@@ -7002,7 +6925,7 @@
                 <a:solidFill>
                   <a:srgbClr val="404040"/>
                 </a:solidFill>
-                <a:latin typeface="Century Gothic"/>
+                <a:latin typeface="Roboto"/>
               </a:rPr>
               <a:t>다음 1주</a:t>
             </a:r>
@@ -7012,41 +6935,6 @@
       <p:sp>
         <p:nvSpPr>
           <p:cNvPr id="4" name="TextBox 3"/>
-          <p:cNvSpPr txBox="1"/>
-          <p:nvPr/>
-        </p:nvSpPr>
-        <p:spPr>
-          <a:xfrm>
-            <a:off x="10213848" y="6601968"/>
-            <a:ext cx="640080" cy="237744"/>
-          </a:xfrm>
-          <a:prstGeom prst="rect">
-            <a:avLst/>
-          </a:prstGeom>
-          <a:noFill/>
-        </p:spPr>
-        <p:txBody>
-          <a:bodyPr wrap="square">
-            <a:spAutoFit/>
-          </a:bodyPr>
-          <a:lstStyle/>
-          <a:p>
-            <a:pPr algn="l"/>
-            <a:r>
-              <a:rPr sz="1200" b="0">
-                <a:solidFill>
-                  <a:srgbClr val="404040"/>
-                </a:solidFill>
-                <a:latin typeface="Century Gothic"/>
-              </a:rPr>
-              <a:t>7</a:t>
-            </a:r>
-          </a:p>
-        </p:txBody>
-      </p:sp>
-      <p:sp>
-        <p:nvSpPr>
-          <p:cNvPr id="5" name="TextBox 4"/>
           <p:cNvSpPr txBox="1"/>
           <p:nvPr/>
         </p:nvSpPr>
@@ -7072,9 +6960,9 @@
                 <a:solidFill>
                   <a:srgbClr val="404040"/>
                 </a:solidFill>
-                <a:latin typeface="Century Gothic"/>
+                <a:latin typeface="Roboto"/>
               </a:rPr>
-              <a:t>• 할 일 한 줄</a:t>
+              <a:t>• 할 일</a:t>
             </a:r>
           </a:p>
           <a:p>
@@ -7084,9 +6972,9 @@
                 <a:solidFill>
                   <a:srgbClr val="404040"/>
                 </a:solidFill>
-                <a:latin typeface="Century Gothic"/>
+                <a:latin typeface="Roboto"/>
               </a:rPr>
-              <a:t>• 할 일 한 줄</a:t>
+              <a:t>• 할 일</a:t>
             </a:r>
           </a:p>
           <a:p>
@@ -7096,9 +6984,9 @@
                 <a:solidFill>
                   <a:srgbClr val="404040"/>
                 </a:solidFill>
-                <a:latin typeface="Century Gothic"/>
+                <a:latin typeface="Roboto"/>
               </a:rPr>
-              <a:t>• 할 일 한 줄</a:t>
+              <a:t>• 할 일</a:t>
             </a:r>
           </a:p>
         </p:txBody>
@@ -7135,21 +7023,25 @@
           <a:prstGeom prst="rect">
             <a:avLst/>
           </a:prstGeom>
-          <a:noFill/>
+          <a:solidFill>
+            <a:srgbClr val="202843"/>
+          </a:solidFill>
+          <a:ln>
+            <a:noFill/>
+          </a:ln>
         </p:spPr>
         <p:txBody>
-          <a:bodyPr wrap="square">
+          <a:bodyPr wrap="none" lIns="164592" tIns="18288">
             <a:spAutoFit/>
           </a:bodyPr>
           <a:lstStyle/>
           <a:p>
-            <a:pPr algn="l"/>
-            <a:r>
-              <a:rPr sz="2800" b="0">
+            <a:r>
+              <a:rPr sz="2800">
                 <a:solidFill>
-                  <a:srgbClr val="404040"/>
+                  <a:srgbClr val="FFFFFF"/>
                 </a:solidFill>
-                <a:latin typeface="Century Gothic"/>
+                <a:latin typeface="Roboto"/>
               </a:rPr>
               <a:t>4. Reference</a:t>
             </a:r>
@@ -7159,41 +7051,6 @@
       <p:sp>
         <p:nvSpPr>
           <p:cNvPr id="3" name="TextBox 2"/>
-          <p:cNvSpPr txBox="1"/>
-          <p:nvPr/>
-        </p:nvSpPr>
-        <p:spPr>
-          <a:xfrm>
-            <a:off x="10213848" y="6601968"/>
-            <a:ext cx="640080" cy="237744"/>
-          </a:xfrm>
-          <a:prstGeom prst="rect">
-            <a:avLst/>
-          </a:prstGeom>
-          <a:noFill/>
-        </p:spPr>
-        <p:txBody>
-          <a:bodyPr wrap="square">
-            <a:spAutoFit/>
-          </a:bodyPr>
-          <a:lstStyle/>
-          <a:p>
-            <a:pPr algn="l"/>
-            <a:r>
-              <a:rPr sz="1200" b="0">
-                <a:solidFill>
-                  <a:srgbClr val="404040"/>
-                </a:solidFill>
-                <a:latin typeface="Century Gothic"/>
-              </a:rPr>
-              <a:t>8</a:t>
-            </a:r>
-          </a:p>
-        </p:txBody>
-      </p:sp>
-      <p:sp>
-        <p:nvSpPr>
-          <p:cNvPr id="4" name="TextBox 3"/>
           <p:cNvSpPr txBox="1"/>
           <p:nvPr/>
         </p:nvSpPr>
@@ -7219,21 +7076,9 @@
                 <a:solidFill>
                   <a:srgbClr val="404040"/>
                 </a:solidFill>
-                <a:latin typeface="Century Gothic"/>
+                <a:latin typeface="Roboto"/>
               </a:rPr>
               <a:t>[1] Author, "Title," Venue, Year.</a:t>
-            </a:r>
-          </a:p>
-          <a:p>
-            <a:pPr algn="l"/>
-            <a:r>
-              <a:rPr sz="1200" b="0">
-                <a:solidFill>
-                  <a:srgbClr val="404040"/>
-                </a:solidFill>
-                <a:latin typeface="Century Gothic"/>
-              </a:rPr>
-              <a:t>[2] ...</a:t>
             </a:r>
           </a:p>
         </p:txBody>
@@ -7289,13 +7134,13 @@
     </a:clrScheme>
     <a:fontScheme name="Custom 3">
       <a:majorFont>
-        <a:latin typeface="Century Gothic"/>
-        <a:ea typeface="Century Gothic"/>
+        <a:latin typeface="Roboto"/>
+        <a:ea typeface="Arial"/>
         <a:cs typeface="Arial"/>
       </a:majorFont>
       <a:minorFont>
-        <a:latin typeface="Century Gothic"/>
-        <a:ea typeface="Century Gothic"/>
+        <a:latin typeface="Roboto"/>
+        <a:ea typeface="Arial"/>
         <a:cs typeface="Arial"/>
       </a:minorFont>
     </a:fontScheme>
@@ -7485,13 +7330,13 @@
     </a:clrScheme>
     <a:fontScheme name="Module">
       <a:majorFont>
-        <a:latin typeface="Century Gothic"/>
-        <a:ea typeface="Century Gothic"/>
+        <a:latin typeface="Roboto"/>
+        <a:ea typeface="Arial"/>
         <a:cs typeface="Arial"/>
       </a:majorFont>
       <a:minorFont>
-        <a:latin typeface="Century Gothic"/>
-        <a:ea typeface="Century Gothic"/>
+        <a:latin typeface="Roboto"/>
+        <a:ea typeface="Arial"/>
         <a:cs typeface="Arial"/>
       </a:minorFont>
     </a:fontScheme>

</xml_diff>

<commit_message>
fix(ppt): kill inherited list bullets and green table banding
둘 다 상속받은 서식이 원인이었다.

- 목차: 레이아웃이 자동 번호를 물려주는데 본문에도 `1.` 을 직접 써서
  `1. 1. Summary ...` 로 두 번 찍혔다. 문단마다 `buNone` 으로 껐다.
- 표: 본문 행이 PowerPoint 기본 표 스타일의 초록 밴딩을 그대로 쓰고
  있었다. `tblPr` 의 bandRow/firstRow 플래그를 내리고 셀마다 직접 칠한다.
  본문 행 색은 `202843` 을 흰색에 12% / 5% 섞은 `E8EAF0` / `F6F7F9`.

Co-Authored-By: Claude Opus 4.8 <noreply@anthropic.com>
Claude-Session: https://claude.ai/code/session_01FfKQPAstkv5E1GtvR5op9j
</commit_message>
<xml_diff>
--- a/ppt/template/radp-progress-template.pptx
+++ b/ppt/template/radp-progress-template.pptx
@@ -5530,10 +5530,10 @@
           </a:bodyPr>
           <a:lstStyle/>
           <a:p>
-            <a:pPr marL="502920" indent="-457200">
+            <a:pPr marL="0" indent="0">
               <a:buFont typeface="Wingdings"/>
-              <a:buAutoNum type="arabicPeriod"/>
-              <a:defRPr/>
+              <a:defRPr/>
+              <a:buNone/>
             </a:pPr>
             <a:r>
               <a:rPr sz="2400">
@@ -5547,6 +5547,9 @@
             <a:endParaRPr/>
           </a:p>
           <a:p>
+            <a:pPr marL="0" indent="0">
+              <a:buNone/>
+            </a:pPr>
             <a:r>
               <a:rPr sz="2400">
                 <a:solidFill>
@@ -5558,6 +5561,9 @@
             </a:r>
           </a:p>
           <a:p>
+            <a:pPr marL="0" indent="0">
+              <a:buNone/>
+            </a:pPr>
             <a:r>
               <a:rPr sz="2400">
                 <a:solidFill>
@@ -5569,6 +5575,9 @@
             </a:r>
           </a:p>
           <a:p>
+            <a:pPr marL="0" indent="0">
+              <a:buNone/>
+            </a:pPr>
             <a:r>
               <a:rPr sz="2400">
                 <a:solidFill>
@@ -5744,7 +5753,7 @@
         <a:graphic>
           <a:graphicData uri="http://schemas.openxmlformats.org/drawingml/2006/table">
             <a:tbl>
-              <a:tblPr firstRow="1" bandRow="1">
+              <a:tblPr firstRow="0" bandRow="0" firstCol="0" bandCol="0" lastRow="0" lastCol="0">
                 <a:tableStyleId>{5C22544A-7EE6-4342-B048-85BDC9FD1C3A}</a:tableStyleId>
               </a:tblPr>
               <a:tblGrid>
@@ -5814,7 +5823,11 @@
                       </a:r>
                     </a:p>
                   </a:txBody>
-                  <a:tcPr/>
+                  <a:tcPr>
+                    <a:solidFill>
+                      <a:srgbClr val="E8EAF0"/>
+                    </a:solidFill>
+                  </a:tcPr>
                 </a:tc>
                 <a:tc>
                   <a:txBody>
@@ -5832,7 +5845,11 @@
                       </a:r>
                     </a:p>
                   </a:txBody>
-                  <a:tcPr/>
+                  <a:tcPr>
+                    <a:solidFill>
+                      <a:srgbClr val="E8EAF0"/>
+                    </a:solidFill>
+                  </a:tcPr>
                 </a:tc>
               </a:tr>
               <a:tr h="685800">
@@ -5852,7 +5869,11 @@
                       </a:r>
                     </a:p>
                   </a:txBody>
-                  <a:tcPr/>
+                  <a:tcPr>
+                    <a:solidFill>
+                      <a:srgbClr val="F6F7F9"/>
+                    </a:solidFill>
+                  </a:tcPr>
                 </a:tc>
                 <a:tc>
                   <a:txBody>
@@ -5870,7 +5891,11 @@
                       </a:r>
                     </a:p>
                   </a:txBody>
-                  <a:tcPr/>
+                  <a:tcPr>
+                    <a:solidFill>
+                      <a:srgbClr val="F6F7F9"/>
+                    </a:solidFill>
+                  </a:tcPr>
                 </a:tc>
               </a:tr>
               <a:tr h="685800">
@@ -5890,7 +5915,11 @@
                       </a:r>
                     </a:p>
                   </a:txBody>
-                  <a:tcPr/>
+                  <a:tcPr>
+                    <a:solidFill>
+                      <a:srgbClr val="E8EAF0"/>
+                    </a:solidFill>
+                  </a:tcPr>
                 </a:tc>
                 <a:tc>
                   <a:txBody>
@@ -5908,7 +5937,11 @@
                       </a:r>
                     </a:p>
                   </a:txBody>
-                  <a:tcPr/>
+                  <a:tcPr>
+                    <a:solidFill>
+                      <a:srgbClr val="E8EAF0"/>
+                    </a:solidFill>
+                  </a:tcPr>
                 </a:tc>
               </a:tr>
             </a:tbl>
@@ -6557,7 +6590,7 @@
         <a:graphic>
           <a:graphicData uri="http://schemas.openxmlformats.org/drawingml/2006/table">
             <a:tbl>
-              <a:tblPr firstRow="1" bandRow="1">
+              <a:tblPr firstRow="0" bandRow="0" firstCol="0" bandCol="0" lastRow="0" lastCol="0">
                 <a:tableStyleId>{5C22544A-7EE6-4342-B048-85BDC9FD1C3A}</a:tableStyleId>
               </a:tblPr>
               <a:tblGrid>
@@ -6650,7 +6683,11 @@
                       </a:r>
                     </a:p>
                   </a:txBody>
-                  <a:tcPr/>
+                  <a:tcPr>
+                    <a:solidFill>
+                      <a:srgbClr val="E8EAF0"/>
+                    </a:solidFill>
+                  </a:tcPr>
                 </a:tc>
                 <a:tc>
                   <a:txBody>
@@ -6668,7 +6705,11 @@
                       </a:r>
                     </a:p>
                   </a:txBody>
-                  <a:tcPr/>
+                  <a:tcPr>
+                    <a:solidFill>
+                      <a:srgbClr val="E8EAF0"/>
+                    </a:solidFill>
+                  </a:tcPr>
                 </a:tc>
                 <a:tc>
                   <a:txBody>
@@ -6686,7 +6727,11 @@
                       </a:r>
                     </a:p>
                   </a:txBody>
-                  <a:tcPr/>
+                  <a:tcPr>
+                    <a:solidFill>
+                      <a:srgbClr val="E8EAF0"/>
+                    </a:solidFill>
+                  </a:tcPr>
                 </a:tc>
               </a:tr>
               <a:tr h="594360">
@@ -6706,7 +6751,11 @@
                       </a:r>
                     </a:p>
                   </a:txBody>
-                  <a:tcPr/>
+                  <a:tcPr>
+                    <a:solidFill>
+                      <a:srgbClr val="F6F7F9"/>
+                    </a:solidFill>
+                  </a:tcPr>
                 </a:tc>
                 <a:tc>
                   <a:txBody>
@@ -6724,7 +6773,11 @@
                       </a:r>
                     </a:p>
                   </a:txBody>
-                  <a:tcPr/>
+                  <a:tcPr>
+                    <a:solidFill>
+                      <a:srgbClr val="F6F7F9"/>
+                    </a:solidFill>
+                  </a:tcPr>
                 </a:tc>
                 <a:tc>
                   <a:txBody>
@@ -6742,7 +6795,11 @@
                       </a:r>
                     </a:p>
                   </a:txBody>
-                  <a:tcPr/>
+                  <a:tcPr>
+                    <a:solidFill>
+                      <a:srgbClr val="F6F7F9"/>
+                    </a:solidFill>
+                  </a:tcPr>
                 </a:tc>
               </a:tr>
               <a:tr h="594360">
@@ -6762,7 +6819,11 @@
                       </a:r>
                     </a:p>
                   </a:txBody>
-                  <a:tcPr/>
+                  <a:tcPr>
+                    <a:solidFill>
+                      <a:srgbClr val="E8EAF0"/>
+                    </a:solidFill>
+                  </a:tcPr>
                 </a:tc>
                 <a:tc>
                   <a:txBody>
@@ -6780,7 +6841,11 @@
                       </a:r>
                     </a:p>
                   </a:txBody>
-                  <a:tcPr/>
+                  <a:tcPr>
+                    <a:solidFill>
+                      <a:srgbClr val="E8EAF0"/>
+                    </a:solidFill>
+                  </a:tcPr>
                 </a:tc>
                 <a:tc>
                   <a:txBody>
@@ -6798,7 +6863,11 @@
                       </a:r>
                     </a:p>
                   </a:txBody>
-                  <a:tcPr/>
+                  <a:tcPr>
+                    <a:solidFill>
+                      <a:srgbClr val="E8EAF0"/>
+                    </a:solidFill>
+                  </a:tcPr>
                 </a:tc>
               </a:tr>
             </a:tbl>

</xml_diff>

<commit_message>
docs(ppt): state that patterns are assets, not a fixed 8-slide skeleton
§8 카탈로그가 "P4 표 중심 → 템플릿 6번" 처럼 1:1 로 적혀 있어서 패턴을
한 장씩만 쓰라는 뜻으로 읽혔다. §1 은 이미 §2 를 3~6장으로 잡고 §0 은
"복제해서 채운다" 라고 하는데 §8 만 어긋나 있었다.

패턴은 몇 번이든 복제하고, 안 쓰는 패턴은 지우고, 총 장수는 내용이
정한다는 것을 명시. 고정되는 건 섹션 4개와 좌표·폰트·색·규격뿐이다.

Co-Authored-By: Claude Opus 4.8 <noreply@anthropic.com>
Claude-Session: https://claude.ai/code/session_01FfKQPAstkv5E1GtvR5op9j
</commit_message>
<xml_diff>
--- a/ppt/template/radp-progress-template.pptx
+++ b/ppt/template/radp-progress-template.pptx
@@ -1,21 +1,21 @@
 
 <file path=ppt/presentation.xml><?xml version="1.0" encoding="utf-8"?>
-<p:presentation xmlns:a="http://schemas.openxmlformats.org/drawingml/2006/main" xmlns:r="http://schemas.openxmlformats.org/officeDocument/2006/relationships" xmlns:p="http://schemas.openxmlformats.org/presentationml/2006/main" xmlns:m="http://schemas.openxmlformats.org/officeDocument/2006/math" xmlns:w="http://schemas.openxmlformats.org/wordprocessingml/2006/main" saveSubsetFonts="1">
+<p:presentation xmlns:a="http://schemas.openxmlformats.org/drawingml/2006/main" xmlns:r="http://schemas.openxmlformats.org/officeDocument/2006/relationships" xmlns:p="http://schemas.openxmlformats.org/presentationml/2006/main" saveSubsetFonts="1">
   <p:sldMasterIdLst>
     <p:sldMasterId id="2147483648" r:id="rId1"/>
   </p:sldMasterIdLst>
   <p:notesMasterIdLst>
-    <p:notesMasterId r:id="rId28"/>
+    <p:notesMasterId r:id="rId10"/>
   </p:notesMasterIdLst>
   <p:sldIdLst>
-    <p:sldId id="256" r:id="rId4"/>
-    <p:sldId id="257" r:id="rId5"/>
-    <p:sldId id="258" r:id="rId10"/>
-    <p:sldId id="259" r:id="rId11"/>
-    <p:sldId id="260" r:id="rId12"/>
-    <p:sldId id="261" r:id="rId13"/>
-    <p:sldId id="262" r:id="rId14"/>
-    <p:sldId id="263" r:id="rId15"/>
+    <p:sldId id="256" r:id="rId2"/>
+    <p:sldId id="257" r:id="rId3"/>
+    <p:sldId id="258" r:id="rId4"/>
+    <p:sldId id="259" r:id="rId5"/>
+    <p:sldId id="260" r:id="rId6"/>
+    <p:sldId id="261" r:id="rId7"/>
+    <p:sldId id="262" r:id="rId8"/>
+    <p:sldId id="263" r:id="rId9"/>
   </p:sldIdLst>
   <p:sldSz cx="12192000" cy="6858000"/>
   <p:notesSz cx="6802438" cy="9934575"/>
@@ -114,12 +114,38 @@
       </a:defRPr>
     </a:lvl9pPr>
   </p:defaultTextStyle>
+  <p:extLst>
+    <p:ext uri="{EFAFB233-063F-42B5-8137-9DF3F51BA10A}">
+      <p15:sldGuideLst xmlns:p15="http://schemas.microsoft.com/office/powerpoint/2012/main">
+        <p15:guide id="1" pos="3840">
+          <p15:clr>
+            <a:srgbClr val="A4A3A4"/>
+          </p15:clr>
+        </p15:guide>
+        <p15:guide id="2" pos="6816">
+          <p15:clr>
+            <a:srgbClr val="A4A3A4"/>
+          </p15:clr>
+        </p15:guide>
+        <p15:guide id="3" pos="816">
+          <p15:clr>
+            <a:srgbClr val="A4A3A4"/>
+          </p15:clr>
+        </p15:guide>
+        <p15:guide id="4" orient="horz" pos="2160">
+          <p15:clr>
+            <a:srgbClr val="A4A3A4"/>
+          </p15:clr>
+        </p15:guide>
+      </p15:sldGuideLst>
+    </p:ext>
+  </p:extLst>
 </p:presentation>
 </file>
 
 <file path=ppt/notesMasters/notesMaster1.xml><?xml version="1.0" encoding="utf-8"?>
 <p:notesMaster xmlns:a="http://schemas.openxmlformats.org/drawingml/2006/main" xmlns:r="http://schemas.openxmlformats.org/officeDocument/2006/relationships" xmlns:p="http://schemas.openxmlformats.org/presentationml/2006/main">
-  <p:cSld name="">
+  <p:cSld>
     <p:bg>
       <p:bgRef idx="1001">
         <a:schemeClr val="bg1"/>
@@ -205,7 +231,7 @@
             </a:pPr>
             <a:fld id="{A8CDE508-72C8-4AB5-AA9C-1584D31690E0}" type="datetimeFigureOut">
               <a:rPr lang="en-US"/>
-              <a:t>8/21/2024</a:t>
+              <a:t>7/20/26</a:t>
             </a:fld>
             <a:endParaRPr/>
           </a:p>
@@ -215,7 +241,7 @@
         <p:nvSpPr>
           <p:cNvPr id="4" name="Slide Image Placeholder 3"/>
           <p:cNvSpPr>
-            <a:spLocks noChangeAspect="1" noGrp="1" noRot="1"/>
+            <a:spLocks noGrp="1" noRot="1" noChangeAspect="1"/>
           </p:cNvSpPr>
           <p:nvPr>
             <p:ph type="sldImg" idx="2"/>
@@ -274,50 +300,40 @@
               <a:defRPr/>
             </a:pPr>
             <a:r>
-              <a:rPr/>
               <a:t>Click to edit Master text styles</a:t>
             </a:r>
-            <a:endParaRPr/>
           </a:p>
           <a:p>
             <a:pPr lvl="1">
               <a:defRPr/>
             </a:pPr>
             <a:r>
-              <a:rPr/>
               <a:t>Second level</a:t>
             </a:r>
-            <a:endParaRPr/>
           </a:p>
           <a:p>
             <a:pPr lvl="2">
               <a:defRPr/>
             </a:pPr>
             <a:r>
-              <a:rPr/>
               <a:t>Third level</a:t>
             </a:r>
-            <a:endParaRPr/>
           </a:p>
           <a:p>
             <a:pPr lvl="3">
               <a:defRPr/>
             </a:pPr>
             <a:r>
-              <a:rPr/>
               <a:t>Fourth level</a:t>
             </a:r>
-            <a:endParaRPr/>
           </a:p>
           <a:p>
             <a:pPr lvl="4">
               <a:defRPr/>
             </a:pPr>
             <a:r>
-              <a:rPr/>
               <a:t>Fifth level</a:t>
             </a:r>
-            <a:endParaRPr/>
           </a:p>
         </p:txBody>
       </p:sp>
@@ -396,7 +412,7 @@
     </p:spTree>
   </p:cSld>
   <p:clrMap bg1="lt1" tx1="dk1" bg2="lt2" tx2="dk2" accent1="accent1" accent2="accent2" accent3="accent3" accent4="accent4" accent5="accent5" accent6="accent6" hlink="hlink" folHlink="folHlink"/>
-  <p:hf dt="0" ftr="0" hdr="0" sldNum="1"/>
+  <p:hf hdr="0" ftr="0" dt="0"/>
   <p:notesStyle>
     <a:lvl1pPr marL="0" algn="l" defTabSz="914400">
       <a:defRPr sz="1200">
@@ -493,8 +509,8 @@
 </file>
 
 <file path=ppt/notesSlides/notesSlide1.xml><?xml version="1.0" encoding="utf-8"?>
-<p:notes xmlns:a="http://schemas.openxmlformats.org/drawingml/2006/main" xmlns:r="http://schemas.openxmlformats.org/officeDocument/2006/relationships" xmlns:p="http://schemas.openxmlformats.org/presentationml/2006/main" xmlns:m="http://schemas.openxmlformats.org/officeDocument/2006/math" xmlns:w="http://schemas.openxmlformats.org/wordprocessingml/2006/main">
-  <p:cSld name="">
+<p:notes xmlns:a="http://schemas.openxmlformats.org/drawingml/2006/main" xmlns:r="http://schemas.openxmlformats.org/officeDocument/2006/relationships" xmlns:p="http://schemas.openxmlformats.org/presentationml/2006/main">
+  <p:cSld>
     <p:spTree>
       <p:nvGrpSpPr>
         <p:cNvPr id="1" name=""/>
@@ -513,7 +529,7 @@
         <p:nvSpPr>
           <p:cNvPr id="2" name="Slide Image Placeholder 1"/>
           <p:cNvSpPr>
-            <a:spLocks noChangeAspect="1" noGrp="1" noRot="1"/>
+            <a:spLocks noGrp="1" noRot="1" noChangeAspect="1"/>
           </p:cNvSpPr>
           <p:nvPr>
             <p:ph type="sldImg"/>
@@ -571,12 +587,15 @@
       </p:sp>
     </p:spTree>
   </p:cSld>
+  <p:clrMapOvr>
+    <a:masterClrMapping/>
+  </p:clrMapOvr>
 </p:notes>
 </file>
 
 <file path=ppt/notesSlides/notesSlide2.xml><?xml version="1.0" encoding="utf-8"?>
-<p:notes xmlns:a="http://schemas.openxmlformats.org/drawingml/2006/main" xmlns:r="http://schemas.openxmlformats.org/officeDocument/2006/relationships" xmlns:p="http://schemas.openxmlformats.org/presentationml/2006/main" xmlns:m="http://schemas.openxmlformats.org/officeDocument/2006/math" xmlns:w="http://schemas.openxmlformats.org/wordprocessingml/2006/main">
-  <p:cSld name="">
+<p:notes xmlns:a="http://schemas.openxmlformats.org/drawingml/2006/main" xmlns:r="http://schemas.openxmlformats.org/officeDocument/2006/relationships" xmlns:p="http://schemas.openxmlformats.org/presentationml/2006/main">
+  <p:cSld>
     <p:spTree>
       <p:nvGrpSpPr>
         <p:cNvPr id="1" name=""/>
@@ -595,7 +614,7 @@
         <p:nvSpPr>
           <p:cNvPr id="2" name="Slide Image Placeholder 1"/>
           <p:cNvSpPr>
-            <a:spLocks noChangeAspect="1" noGrp="1" noRot="1"/>
+            <a:spLocks noGrp="1" noRot="1" noChangeAspect="1"/>
           </p:cNvSpPr>
           <p:nvPr>
             <p:ph type="sldImg"/>
@@ -673,11 +692,14 @@
       </p:sp>
     </p:spTree>
   </p:cSld>
+  <p:clrMapOvr>
+    <a:masterClrMapping/>
+  </p:clrMapOvr>
 </p:notes>
 </file>
 
 <file path=ppt/slideLayouts/slideLayout1.xml><?xml version="1.0" encoding="utf-8"?>
-<p:sldLayout xmlns:a="http://schemas.openxmlformats.org/drawingml/2006/main" xmlns:r="http://schemas.openxmlformats.org/officeDocument/2006/relationships" xmlns:p="http://schemas.openxmlformats.org/presentationml/2006/main" xmlns:m="http://schemas.openxmlformats.org/officeDocument/2006/math" xmlns:w="http://schemas.openxmlformats.org/wordprocessingml/2006/main" matchingName="" preserve="1" showMasterPhAnim="0" showMasterSp="0" type="title" userDrawn="1">
+<p:sldLayout xmlns:a="http://schemas.openxmlformats.org/drawingml/2006/main" xmlns:r="http://schemas.openxmlformats.org/officeDocument/2006/relationships" xmlns:p="http://schemas.openxmlformats.org/presentationml/2006/main" showMasterSp="0" showMasterPhAnim="0" type="title" preserve="1" userDrawn="1">
   <p:cSld name="Title Slide">
     <p:spTree>
       <p:nvGrpSpPr>
@@ -956,7 +978,7 @@
 </file>
 
 <file path=ppt/slideLayouts/slideLayout10.xml><?xml version="1.0" encoding="utf-8"?>
-<p:sldLayout xmlns:a="http://schemas.openxmlformats.org/drawingml/2006/main" xmlns:r="http://schemas.openxmlformats.org/officeDocument/2006/relationships" xmlns:p="http://schemas.openxmlformats.org/presentationml/2006/main" xmlns:m="http://schemas.openxmlformats.org/officeDocument/2006/math" xmlns:w="http://schemas.openxmlformats.org/wordprocessingml/2006/main" matchingName="" preserve="1" showMasterPhAnim="0" showMasterSp="0" type="objTx" userDrawn="1">
+<p:sldLayout xmlns:a="http://schemas.openxmlformats.org/drawingml/2006/main" xmlns:r="http://schemas.openxmlformats.org/officeDocument/2006/relationships" xmlns:p="http://schemas.openxmlformats.org/presentationml/2006/main" showMasterSp="0" showMasterPhAnim="0" type="objTx" preserve="1" userDrawn="1">
   <p:cSld name="Alternate Content with Caption">
     <p:spTree>
       <p:nvGrpSpPr>
@@ -1312,7 +1334,7 @@
             </a:pPr>
             <a:fld id="{B43F99CD-2C18-4A2E-8316-6DD2578C3BFD}" type="datetime1">
               <a:rPr lang="en-US"/>
-              <a:t>8/21/2024</a:t>
+              <a:t>7/20/26</a:t>
             </a:fld>
             <a:endParaRPr/>
           </a:p>
@@ -1361,7 +1383,7 @@
 </file>
 
 <file path=ppt/slideLayouts/slideLayout11.xml><?xml version="1.0" encoding="utf-8"?>
-<p:sldLayout xmlns:a="http://schemas.openxmlformats.org/drawingml/2006/main" xmlns:r="http://schemas.openxmlformats.org/officeDocument/2006/relationships" xmlns:p="http://schemas.openxmlformats.org/presentationml/2006/main" xmlns:m="http://schemas.openxmlformats.org/officeDocument/2006/math" xmlns:w="http://schemas.openxmlformats.org/wordprocessingml/2006/main" matchingName="" preserve="1" showMasterPhAnim="0" showMasterSp="0" type="picTx" userDrawn="1">
+<p:sldLayout xmlns:a="http://schemas.openxmlformats.org/drawingml/2006/main" xmlns:r="http://schemas.openxmlformats.org/officeDocument/2006/relationships" xmlns:p="http://schemas.openxmlformats.org/presentationml/2006/main" showMasterSp="0" showMasterPhAnim="0" type="picTx" preserve="1" userDrawn="1">
   <p:cSld name="Picture with Caption">
     <p:spTree>
       <p:nvGrpSpPr>
@@ -1688,7 +1710,7 @@
             </a:pPr>
             <a:fld id="{BCA953EF-EC43-4647-B8AE-539F1EE3834D}" type="datetime1">
               <a:rPr lang="en-US"/>
-              <a:t>8/21/2024</a:t>
+              <a:t>7/20/26</a:t>
             </a:fld>
             <a:endParaRPr/>
           </a:p>
@@ -1729,7 +1751,7 @@
 </file>
 
 <file path=ppt/slideLayouts/slideLayout12.xml><?xml version="1.0" encoding="utf-8"?>
-<p:sldLayout xmlns:a="http://schemas.openxmlformats.org/drawingml/2006/main" xmlns:r="http://schemas.openxmlformats.org/officeDocument/2006/relationships" xmlns:p="http://schemas.openxmlformats.org/presentationml/2006/main" xmlns:m="http://schemas.openxmlformats.org/officeDocument/2006/math" xmlns:w="http://schemas.openxmlformats.org/wordprocessingml/2006/main" matchingName="" preserve="1" showMasterPhAnim="0" showMasterSp="1" type="vertTx" userDrawn="1">
+<p:sldLayout xmlns:a="http://schemas.openxmlformats.org/drawingml/2006/main" xmlns:r="http://schemas.openxmlformats.org/officeDocument/2006/relationships" xmlns:p="http://schemas.openxmlformats.org/presentationml/2006/main" showMasterPhAnim="0" type="vertTx" preserve="1" userDrawn="1">
   <p:cSld name="Title and Vertical Text">
     <p:spTree>
       <p:nvGrpSpPr>
@@ -1883,7 +1905,7 @@
             </a:pPr>
             <a:fld id="{5854C4A4-9779-4099-B329-474746D321FE}" type="datetime1">
               <a:rPr lang="en-US"/>
-              <a:t>8/21/2024</a:t>
+              <a:t>7/20/26</a:t>
             </a:fld>
             <a:endParaRPr/>
           </a:p>
@@ -1924,7 +1946,7 @@
 </file>
 
 <file path=ppt/slideLayouts/slideLayout13.xml><?xml version="1.0" encoding="utf-8"?>
-<p:sldLayout xmlns:a="http://schemas.openxmlformats.org/drawingml/2006/main" xmlns:r="http://schemas.openxmlformats.org/officeDocument/2006/relationships" xmlns:p="http://schemas.openxmlformats.org/presentationml/2006/main" xmlns:m="http://schemas.openxmlformats.org/officeDocument/2006/math" xmlns:w="http://schemas.openxmlformats.org/wordprocessingml/2006/main" matchingName="" preserve="1" showMasterPhAnim="0" showMasterSp="1" type="vertTitleAndTx" userDrawn="1">
+<p:sldLayout xmlns:a="http://schemas.openxmlformats.org/drawingml/2006/main" xmlns:r="http://schemas.openxmlformats.org/officeDocument/2006/relationships" xmlns:p="http://schemas.openxmlformats.org/presentationml/2006/main" showMasterPhAnim="0" type="vertTitleAndTx" preserve="1" userDrawn="1">
   <p:cSld name="Vertical Title and Text">
     <p:spTree>
       <p:nvGrpSpPr>
@@ -2088,7 +2110,7 @@
             </a:pPr>
             <a:fld id="{5F303420-E7D0-4F09-96D8-181EC29F25F4}" type="datetime1">
               <a:rPr lang="en-US"/>
-              <a:t>8/21/2024</a:t>
+              <a:t>7/20/26</a:t>
             </a:fld>
             <a:endParaRPr/>
           </a:p>
@@ -2129,7 +2151,7 @@
 </file>
 
 <file path=ppt/slideLayouts/slideLayout2.xml><?xml version="1.0" encoding="utf-8"?>
-<p:sldLayout xmlns:a="http://schemas.openxmlformats.org/drawingml/2006/main" xmlns:r="http://schemas.openxmlformats.org/officeDocument/2006/relationships" xmlns:p="http://schemas.openxmlformats.org/presentationml/2006/main" xmlns:m="http://schemas.openxmlformats.org/officeDocument/2006/math" xmlns:w="http://schemas.openxmlformats.org/wordprocessingml/2006/main" matchingName="" preserve="1" showMasterPhAnim="0" showMasterSp="1" type="obj" userDrawn="1">
+<p:sldLayout xmlns:a="http://schemas.openxmlformats.org/drawingml/2006/main" xmlns:r="http://schemas.openxmlformats.org/officeDocument/2006/relationships" xmlns:p="http://schemas.openxmlformats.org/presentationml/2006/main" showMasterPhAnim="0" type="obj" preserve="1" userDrawn="1">
   <p:cSld name="Title and Content">
     <p:spTree>
       <p:nvGrpSpPr>
@@ -2287,7 +2309,7 @@
             </a:pPr>
             <a:fld id="{42536CB8-F384-41F5-9A13-5525A14F6115}" type="datetime1">
               <a:rPr lang="en-US"/>
-              <a:t>8/21/2024</a:t>
+              <a:t>7/20/26</a:t>
             </a:fld>
             <a:endParaRPr/>
           </a:p>
@@ -2328,7 +2350,7 @@
 </file>
 
 <file path=ppt/slideLayouts/slideLayout3.xml><?xml version="1.0" encoding="utf-8"?>
-<p:sldLayout xmlns:a="http://schemas.openxmlformats.org/drawingml/2006/main" xmlns:r="http://schemas.openxmlformats.org/officeDocument/2006/relationships" xmlns:p="http://schemas.openxmlformats.org/presentationml/2006/main" xmlns:m="http://schemas.openxmlformats.org/officeDocument/2006/math" xmlns:w="http://schemas.openxmlformats.org/wordprocessingml/2006/main" matchingName="" preserve="1" showMasterPhAnim="0" showMasterSp="1" type="secHead" userDrawn="1">
+<p:sldLayout xmlns:a="http://schemas.openxmlformats.org/drawingml/2006/main" xmlns:r="http://schemas.openxmlformats.org/officeDocument/2006/relationships" xmlns:p="http://schemas.openxmlformats.org/presentationml/2006/main" showMasterPhAnim="0" type="secHead" preserve="1" userDrawn="1">
   <p:cSld name="Section Header">
     <p:spTree>
       <p:nvGrpSpPr>
@@ -2664,7 +2686,7 @@
             </a:pPr>
             <a:fld id="{9A80470E-3E49-4166-8FDE-B4B231F96343}" type="datetime1">
               <a:rPr lang="en-US"/>
-              <a:t>8/21/2024</a:t>
+              <a:t>7/20/26</a:t>
             </a:fld>
             <a:endParaRPr/>
           </a:p>
@@ -2705,7 +2727,7 @@
 </file>
 
 <file path=ppt/slideLayouts/slideLayout4.xml><?xml version="1.0" encoding="utf-8"?>
-<p:sldLayout xmlns:a="http://schemas.openxmlformats.org/drawingml/2006/main" xmlns:r="http://schemas.openxmlformats.org/officeDocument/2006/relationships" xmlns:p="http://schemas.openxmlformats.org/presentationml/2006/main" xmlns:m="http://schemas.openxmlformats.org/officeDocument/2006/math" xmlns:w="http://schemas.openxmlformats.org/wordprocessingml/2006/main" matchingName="" preserve="1" showMasterPhAnim="0" showMasterSp="0" type="secHead" userDrawn="1">
+<p:sldLayout xmlns:a="http://schemas.openxmlformats.org/drawingml/2006/main" xmlns:r="http://schemas.openxmlformats.org/officeDocument/2006/relationships" xmlns:p="http://schemas.openxmlformats.org/presentationml/2006/main" showMasterSp="0" showMasterPhAnim="0" type="secHead" preserve="1" userDrawn="1">
   <p:cSld name="Alternate Section Header">
     <p:spTree>
       <p:nvGrpSpPr>
@@ -2949,7 +2971,7 @@
             </a:pPr>
             <a:fld id="{C9C6305C-FBE6-4432-984C-F014356066E0}" type="datetime1">
               <a:rPr lang="en-US"/>
-              <a:t>8/21/2024</a:t>
+              <a:t>7/20/26</a:t>
             </a:fld>
             <a:endParaRPr/>
           </a:p>
@@ -2998,7 +3020,7 @@
 </file>
 
 <file path=ppt/slideLayouts/slideLayout5.xml><?xml version="1.0" encoding="utf-8"?>
-<p:sldLayout xmlns:a="http://schemas.openxmlformats.org/drawingml/2006/main" xmlns:r="http://schemas.openxmlformats.org/officeDocument/2006/relationships" xmlns:p="http://schemas.openxmlformats.org/presentationml/2006/main" xmlns:m="http://schemas.openxmlformats.org/officeDocument/2006/math" xmlns:w="http://schemas.openxmlformats.org/wordprocessingml/2006/main" matchingName="" preserve="1" showMasterPhAnim="0" showMasterSp="1" type="twoObj" userDrawn="1">
+<p:sldLayout xmlns:a="http://schemas.openxmlformats.org/drawingml/2006/main" xmlns:r="http://schemas.openxmlformats.org/officeDocument/2006/relationships" xmlns:p="http://schemas.openxmlformats.org/presentationml/2006/main" showMasterPhAnim="0" type="twoObj" preserve="1" userDrawn="1">
   <p:cSld name="Two Content">
     <p:spTree>
       <p:nvGrpSpPr>
@@ -3288,7 +3310,7 @@
             </a:pPr>
             <a:fld id="{CF533CFF-D905-4362-8694-2B08F6E2EA39}" type="datetime1">
               <a:rPr lang="en-US"/>
-              <a:t>8/21/2024</a:t>
+              <a:t>7/20/26</a:t>
             </a:fld>
             <a:endParaRPr/>
           </a:p>
@@ -3329,7 +3351,7 @@
 </file>
 
 <file path=ppt/slideLayouts/slideLayout6.xml><?xml version="1.0" encoding="utf-8"?>
-<p:sldLayout xmlns:a="http://schemas.openxmlformats.org/drawingml/2006/main" xmlns:r="http://schemas.openxmlformats.org/officeDocument/2006/relationships" xmlns:p="http://schemas.openxmlformats.org/presentationml/2006/main" xmlns:m="http://schemas.openxmlformats.org/officeDocument/2006/math" xmlns:w="http://schemas.openxmlformats.org/wordprocessingml/2006/main" matchingName="" preserve="1" showMasterPhAnim="0" showMasterSp="1" userDrawn="1">
+<p:sldLayout xmlns:a="http://schemas.openxmlformats.org/drawingml/2006/main" xmlns:r="http://schemas.openxmlformats.org/officeDocument/2006/relationships" xmlns:p="http://schemas.openxmlformats.org/presentationml/2006/main" showMasterPhAnim="0" preserve="1" userDrawn="1">
   <p:cSld name="Comparison">
     <p:spTree>
       <p:nvGrpSpPr>
@@ -3770,7 +3792,7 @@
             </a:pPr>
             <a:fld id="{6F26A8B8-6B3D-4779-A1CC-09767831A91A}" type="datetime1">
               <a:rPr lang="en-US"/>
-              <a:t>8/21/2024</a:t>
+              <a:t>7/20/26</a:t>
             </a:fld>
             <a:endParaRPr/>
           </a:p>
@@ -3811,7 +3833,7 @@
 </file>
 
 <file path=ppt/slideLayouts/slideLayout7.xml><?xml version="1.0" encoding="utf-8"?>
-<p:sldLayout xmlns:a="http://schemas.openxmlformats.org/drawingml/2006/main" xmlns:r="http://schemas.openxmlformats.org/officeDocument/2006/relationships" xmlns:p="http://schemas.openxmlformats.org/presentationml/2006/main" xmlns:m="http://schemas.openxmlformats.org/officeDocument/2006/math" xmlns:w="http://schemas.openxmlformats.org/wordprocessingml/2006/main" matchingName="" preserve="1" showMasterPhAnim="0" showMasterSp="1" type="titleOnly" userDrawn="1">
+<p:sldLayout xmlns:a="http://schemas.openxmlformats.org/drawingml/2006/main" xmlns:r="http://schemas.openxmlformats.org/officeDocument/2006/relationships" xmlns:p="http://schemas.openxmlformats.org/presentationml/2006/main" showMasterPhAnim="0" type="titleOnly" preserve="1" userDrawn="1">
   <p:cSld name="Title Only">
     <p:spTree>
       <p:nvGrpSpPr>
@@ -3899,7 +3921,7 @@
             </a:pPr>
             <a:fld id="{FEE37F0F-C8F1-4757-B6DF-F80D7A79B872}" type="datetime1">
               <a:rPr lang="en-US"/>
-              <a:t>8/21/2024</a:t>
+              <a:t>7/20/26</a:t>
             </a:fld>
             <a:endParaRPr/>
           </a:p>
@@ -3940,7 +3962,7 @@
 </file>
 
 <file path=ppt/slideLayouts/slideLayout8.xml><?xml version="1.0" encoding="utf-8"?>
-<p:sldLayout xmlns:a="http://schemas.openxmlformats.org/drawingml/2006/main" xmlns:r="http://schemas.openxmlformats.org/officeDocument/2006/relationships" xmlns:p="http://schemas.openxmlformats.org/presentationml/2006/main" xmlns:m="http://schemas.openxmlformats.org/officeDocument/2006/math" xmlns:w="http://schemas.openxmlformats.org/wordprocessingml/2006/main" matchingName="" preserve="1" showMasterPhAnim="0" showMasterSp="0" type="blank" userDrawn="1">
+<p:sldLayout xmlns:a="http://schemas.openxmlformats.org/drawingml/2006/main" xmlns:r="http://schemas.openxmlformats.org/officeDocument/2006/relationships" xmlns:p="http://schemas.openxmlformats.org/presentationml/2006/main" showMasterSp="0" showMasterPhAnim="0" type="blank" preserve="1" userDrawn="1">
   <p:cSld name="Blank">
     <p:spTree>
       <p:nvGrpSpPr>
@@ -4018,7 +4040,7 @@
             </a:pPr>
             <a:fld id="{02DFD81F-BFBF-415D-8405-C0F93516B68D}" type="datetime1">
               <a:rPr lang="en-US"/>
-              <a:t>8/21/2024</a:t>
+              <a:t>7/20/26</a:t>
             </a:fld>
             <a:endParaRPr/>
           </a:p>
@@ -4067,7 +4089,7 @@
 </file>
 
 <file path=ppt/slideLayouts/slideLayout9.xml><?xml version="1.0" encoding="utf-8"?>
-<p:sldLayout xmlns:a="http://schemas.openxmlformats.org/drawingml/2006/main" xmlns:r="http://schemas.openxmlformats.org/officeDocument/2006/relationships" xmlns:p="http://schemas.openxmlformats.org/presentationml/2006/main" xmlns:m="http://schemas.openxmlformats.org/officeDocument/2006/math" xmlns:w="http://schemas.openxmlformats.org/wordprocessingml/2006/main" matchingName="" preserve="1" showMasterPhAnim="0" showMasterSp="1" userDrawn="1">
+<p:sldLayout xmlns:a="http://schemas.openxmlformats.org/drawingml/2006/main" xmlns:r="http://schemas.openxmlformats.org/officeDocument/2006/relationships" xmlns:p="http://schemas.openxmlformats.org/presentationml/2006/main" showMasterPhAnim="0" preserve="1" userDrawn="1">
   <p:cSld name="Content with Caption">
     <p:spTree>
       <p:nvGrpSpPr>
@@ -4340,7 +4362,7 @@
             </a:pPr>
             <a:fld id="{83BB29C7-623B-4106-BC28-43A8B3502422}" type="datetime1">
               <a:rPr lang="en-US"/>
-              <a:t>8/21/2024</a:t>
+              <a:t>7/20/26</a:t>
             </a:fld>
             <a:endParaRPr/>
           </a:p>
@@ -4381,8 +4403,8 @@
 </file>
 
 <file path=ppt/slideMasters/slideMaster1.xml><?xml version="1.0" encoding="utf-8"?>
-<p:sldMaster xmlns:a="http://schemas.openxmlformats.org/drawingml/2006/main" xmlns:r="http://schemas.openxmlformats.org/officeDocument/2006/relationships" xmlns:p="http://schemas.openxmlformats.org/presentationml/2006/main" xmlns:m="http://schemas.openxmlformats.org/officeDocument/2006/math" xmlns:w="http://schemas.openxmlformats.org/wordprocessingml/2006/main" preserve="0">
-  <p:cSld name="">
+<p:sldMaster xmlns:a="http://schemas.openxmlformats.org/drawingml/2006/main" xmlns:r="http://schemas.openxmlformats.org/officeDocument/2006/relationships" xmlns:p="http://schemas.openxmlformats.org/presentationml/2006/main">
+  <p:cSld>
     <p:bg>
       <p:bgRef idx="1001">
         <a:schemeClr val="bg1"/>
@@ -4664,7 +4686,6 @@
               <a:rPr lang="en-US"/>
               <a:t>GWANGJU INSTITUTE OF SCIENCE AND TECHNOLOGY (GIST) SEMINAR, JULY 12, 2019</a:t>
             </a:r>
-            <a:endParaRPr lang="en-US"/>
           </a:p>
         </p:txBody>
       </p:sp>
@@ -4704,7 +4725,7 @@
             </a:pPr>
             <a:fld id="{5EAF1AF7-8E07-442A-8E11-2E63F8314A9C}" type="datetime1">
               <a:rPr lang="en-US"/>
-              <a:t>8/21/2024</a:t>
+              <a:t>7/20/26</a:t>
             </a:fld>
             <a:endParaRPr lang="en-US"/>
           </a:p>
@@ -4770,7 +4791,7 @@
     <p:sldLayoutId id="2147483660" r:id="rId12"/>
     <p:sldLayoutId id="2147483661" r:id="rId13"/>
   </p:sldLayoutIdLst>
-  <p:hf dt="0" ftr="1" hdr="0" sldNum="1"/>
+  <p:hf hdr="0" dt="0"/>
   <p:txStyles>
     <p:titleStyle>
       <a:lvl1pPr marL="0" indent="0" algn="l" defTabSz="914400">
@@ -5082,8 +5103,8 @@
 </file>
 
 <file path=ppt/slides/slide1.xml><?xml version="1.0" encoding="utf-8"?>
-<p:sld xmlns:a="http://schemas.openxmlformats.org/drawingml/2006/main" xmlns:r="http://schemas.openxmlformats.org/officeDocument/2006/relationships" xmlns:p="http://schemas.openxmlformats.org/presentationml/2006/main" xmlns:m="http://schemas.openxmlformats.org/officeDocument/2006/math" xmlns:w="http://schemas.openxmlformats.org/wordprocessingml/2006/main" xmlns:mc="http://schemas.openxmlformats.org/markup-compatibility/2006" showMasterPhAnim="0" showMasterSp="1" show="1">
-  <p:cSld name="">
+<p:sld xmlns:a="http://schemas.openxmlformats.org/drawingml/2006/main" xmlns:r="http://schemas.openxmlformats.org/officeDocument/2006/relationships" xmlns:p="http://schemas.openxmlformats.org/presentationml/2006/main" showMasterPhAnim="0">
+  <p:cSld>
     <p:spTree>
       <p:nvGrpSpPr>
         <p:cNvPr id="1" name=""/>
@@ -5128,14 +5149,7 @@
                 <a:latin typeface="Times New Roman"/>
                 <a:cs typeface="Times New Roman"/>
               </a:rPr>
-              <a:t>Hakjae</a:t>
-            </a:r>
-            <a:r>
-              <a:rPr lang="en-US" sz="1200" b="1">
-                <a:latin typeface="Times New Roman"/>
-                <a:cs typeface="Times New Roman"/>
-              </a:rPr>
-              <a:t> Kim</a:t>
+              <a:t>Hakjae Kim</a:t>
             </a:r>
             <a:endParaRPr lang="en-GB" sz="1200">
               <a:latin typeface="Times New Roman"/>
@@ -5151,19 +5165,8 @@
                 <a:latin typeface="Times New Roman"/>
                 <a:cs typeface="Times New Roman"/>
               </a:rPr>
-              <a:t>Department of </a:t>
-            </a:r>
-            <a:r>
-              <a:rPr lang="en-GB" sz="1200">
-                <a:latin typeface="Times New Roman"/>
-                <a:cs typeface="Times New Roman"/>
-              </a:rPr>
-              <a:t>Advanced Materials Science and Engineering</a:t>
-            </a:r>
-            <a:endParaRPr lang="en-GB" sz="1200">
-              <a:latin typeface="Times New Roman"/>
-              <a:cs typeface="Times New Roman"/>
-            </a:endParaRPr>
+              <a:t>Department of Advanced Materials Science and Engineering</a:t>
+            </a:r>
           </a:p>
           <a:p>
             <a:pPr>
@@ -5232,49 +5235,7 @@
                 <a:latin typeface="Times New Roman"/>
                 <a:cs typeface="Times New Roman"/>
               </a:rPr>
-              <a:t>2066, </a:t>
-            </a:r>
-            <a:r>
-              <a:rPr lang="en-GB" sz="1200">
-                <a:latin typeface="Times New Roman"/>
-                <a:cs typeface="Times New Roman"/>
-              </a:rPr>
-              <a:t>Seobu-ro</a:t>
-            </a:r>
-            <a:r>
-              <a:rPr lang="en-GB" sz="1200">
-                <a:latin typeface="Times New Roman"/>
-                <a:cs typeface="Times New Roman"/>
-              </a:rPr>
-              <a:t>, </a:t>
-            </a:r>
-            <a:r>
-              <a:rPr lang="en-GB" sz="1200">
-                <a:latin typeface="Times New Roman"/>
-                <a:cs typeface="Times New Roman"/>
-              </a:rPr>
-              <a:t>Jangan-gu</a:t>
-            </a:r>
-            <a:r>
-              <a:rPr lang="en-GB" sz="1200">
-                <a:latin typeface="Times New Roman"/>
-                <a:cs typeface="Times New Roman"/>
-              </a:rPr>
-              <a:t>, </a:t>
-            </a:r>
-            <a:r>
-              <a:rPr lang="en-GB" sz="1200">
-                <a:latin typeface="Times New Roman"/>
-                <a:cs typeface="Times New Roman"/>
-              </a:rPr>
-              <a:t>Suwon-si</a:t>
-            </a:r>
-            <a:r>
-              <a:rPr lang="en-GB" sz="1200">
-                <a:latin typeface="Times New Roman"/>
-                <a:cs typeface="Times New Roman"/>
-              </a:rPr>
-              <a:t>, Gyeonggi-do, Korea </a:t>
+              <a:t>2066, Seobu-ro, Jangan-gu, Suwon-si, Gyeonggi-do, Korea </a:t>
             </a:r>
             <a:endParaRPr/>
           </a:p>
@@ -5454,20 +5415,12 @@
   <p:clrMapOvr>
     <a:masterClrMapping/>
   </p:clrMapOvr>
-  <mc:AlternateContent xmlns:mc="http://schemas.openxmlformats.org/markup-compatibility/2006">
-    <mc:Choice xmlns:p159="http://schemas.microsoft.com/office/powerpoint/2015/09/main" xmlns:p14="http://schemas.microsoft.com/office/powerpoint/2010/main" Requires="p159">
-      <p:transition p14:dur="2000" advClick="1"/>
-    </mc:Choice>
-    <mc:Fallback>
-      <p:transition advClick="1"/>
-    </mc:Fallback>
-  </mc:AlternateContent>
 </p:sld>
 </file>
 
 <file path=ppt/slides/slide2.xml><?xml version="1.0" encoding="utf-8"?>
-<p:sld xmlns:a="http://schemas.openxmlformats.org/drawingml/2006/main" xmlns:r="http://schemas.openxmlformats.org/officeDocument/2006/relationships" xmlns:p="http://schemas.openxmlformats.org/presentationml/2006/main" xmlns:m="http://schemas.openxmlformats.org/officeDocument/2006/math" xmlns:w="http://schemas.openxmlformats.org/wordprocessingml/2006/main" xmlns:mc="http://schemas.openxmlformats.org/markup-compatibility/2006" showMasterPhAnim="0" showMasterSp="1" show="1">
-  <p:cSld name="">
+<p:sld xmlns:a="http://schemas.openxmlformats.org/drawingml/2006/main" xmlns:r="http://schemas.openxmlformats.org/officeDocument/2006/relationships" xmlns:p="http://schemas.openxmlformats.org/presentationml/2006/main" showMasterPhAnim="0">
+  <p:cSld>
     <p:spTree>
       <p:nvGrpSpPr>
         <p:cNvPr id="1" name=""/>
@@ -5531,9 +5484,8 @@
           <a:lstStyle/>
           <a:p>
             <a:pPr marL="0" indent="0">
-              <a:buFont typeface="Wingdings"/>
-              <a:defRPr/>
-              <a:buNone/>
+              <a:buNone/>
+              <a:defRPr/>
             </a:pPr>
             <a:r>
               <a:rPr sz="2400">
@@ -5542,16 +5494,25 @@
                 </a:solidFill>
                 <a:latin typeface="Roboto"/>
               </a:rPr>
-              <a:t>1. Summary of last meeting/progress</a:t>
-            </a:r>
-            <a:endParaRPr/>
+              <a:t>1. </a:t>
+            </a:r>
+            <a:r>
+              <a:rPr sz="2400" dirty="0">
+                <a:solidFill>
+                  <a:srgbClr val="404040"/>
+                </a:solidFill>
+                <a:latin typeface="Roboto"/>
+              </a:rPr>
+              <a:t>Summary of last meeting/progress</a:t>
+            </a:r>
+            <a:endParaRPr dirty="0"/>
           </a:p>
           <a:p>
             <a:pPr marL="0" indent="0">
               <a:buNone/>
             </a:pPr>
             <a:r>
-              <a:rPr sz="2400">
+              <a:rPr sz="2400" dirty="0">
                 <a:solidFill>
                   <a:srgbClr val="404040"/>
                 </a:solidFill>
@@ -5565,7 +5526,7 @@
               <a:buNone/>
             </a:pPr>
             <a:r>
-              <a:rPr sz="2400">
+              <a:rPr sz="2400" dirty="0">
                 <a:solidFill>
                   <a:srgbClr val="404040"/>
                 </a:solidFill>
@@ -5579,7 +5540,7 @@
               <a:buNone/>
             </a:pPr>
             <a:r>
-              <a:rPr sz="2400">
+              <a:rPr sz="2400" dirty="0">
                 <a:solidFill>
                   <a:srgbClr val="404040"/>
                 </a:solidFill>
@@ -5643,19 +5604,11 @@
   <p:clrMapOvr>
     <a:masterClrMapping/>
   </p:clrMapOvr>
-  <mc:AlternateContent xmlns:mc="http://schemas.openxmlformats.org/markup-compatibility/2006">
-    <mc:Choice xmlns:p159="http://schemas.microsoft.com/office/powerpoint/2015/09/main" xmlns:p14="http://schemas.microsoft.com/office/powerpoint/2010/main" Requires="p159">
-      <p:transition p14:dur="2000" advClick="1"/>
-    </mc:Choice>
-    <mc:Fallback>
-      <p:transition advClick="1"/>
-    </mc:Fallback>
-  </mc:AlternateContent>
 </p:sld>
 </file>
 
 <file path=ppt/slides/slide3.xml><?xml version="1.0" encoding="utf-8"?>
-<p:sld xmlns:a="http://schemas.openxmlformats.org/drawingml/2006/main" xmlns:p="http://schemas.openxmlformats.org/presentationml/2006/main" xmlns:r="http://schemas.openxmlformats.org/officeDocument/2006/relationships">
+<p:sld xmlns:a="http://schemas.openxmlformats.org/drawingml/2006/main" xmlns:r="http://schemas.openxmlformats.org/officeDocument/2006/relationships" xmlns:p="http://schemas.openxmlformats.org/presentationml/2006/main">
   <p:cSld>
     <p:spTree>
       <p:nvGrpSpPr>
@@ -5663,7 +5616,14 @@
         <p:cNvGrpSpPr/>
         <p:nvPr/>
       </p:nvGrpSpPr>
-      <p:grpSpPr/>
+      <p:grpSpPr>
+        <a:xfrm>
+          <a:off x="0" y="0"/>
+          <a:ext cx="0" cy="0"/>
+          <a:chOff x="0" y="0"/>
+          <a:chExt cx="0" cy="0"/>
+        </a:xfrm>
+      </p:grpSpPr>
       <p:sp>
         <p:nvSpPr>
           <p:cNvPr id="2" name="TextBox 1"/>
@@ -5753,12 +5713,24 @@
         <a:graphic>
           <a:graphicData uri="http://schemas.openxmlformats.org/drawingml/2006/table">
             <a:tbl>
-              <a:tblPr firstRow="0" bandRow="0" firstCol="0" bandCol="0" lastRow="0" lastCol="0">
+              <a:tblPr>
                 <a:tableStyleId>{5C22544A-7EE6-4342-B048-85BDC9FD1C3A}</a:tableStyleId>
               </a:tblPr>
               <a:tblGrid>
-                <a:gridCol w="4937760"/>
-                <a:gridCol w="6080760"/>
+                <a:gridCol w="4937760">
+                  <a:extLst>
+                    <a:ext uri="{9D8B030D-6E8A-4147-A177-3AD203B41FA5}">
+                      <a16:colId xmlns:a16="http://schemas.microsoft.com/office/drawing/2014/main" val="20000"/>
+                    </a:ext>
+                  </a:extLst>
+                </a:gridCol>
+                <a:gridCol w="6080760">
+                  <a:extLst>
+                    <a:ext uri="{9D8B030D-6E8A-4147-A177-3AD203B41FA5}">
+                      <a16:colId xmlns:a16="http://schemas.microsoft.com/office/drawing/2014/main" val="20001"/>
+                    </a:ext>
+                  </a:extLst>
+                </a:gridCol>
               </a:tblGrid>
               <a:tr h="685800">
                 <a:tc>
@@ -5805,6 +5777,11 @@
                     </a:solidFill>
                   </a:tcPr>
                 </a:tc>
+                <a:extLst>
+                  <a:ext uri="{0D108BD9-81ED-4DB2-BD59-A6C34878D82A}">
+                    <a16:rowId xmlns:a16="http://schemas.microsoft.com/office/drawing/2014/main" val="10000"/>
+                  </a:ext>
+                </a:extLst>
               </a:tr>
               <a:tr h="685800">
                 <a:tc>
@@ -5851,6 +5828,11 @@
                     </a:solidFill>
                   </a:tcPr>
                 </a:tc>
+                <a:extLst>
+                  <a:ext uri="{0D108BD9-81ED-4DB2-BD59-A6C34878D82A}">
+                    <a16:rowId xmlns:a16="http://schemas.microsoft.com/office/drawing/2014/main" val="10001"/>
+                  </a:ext>
+                </a:extLst>
               </a:tr>
               <a:tr h="685800">
                 <a:tc>
@@ -5897,6 +5879,11 @@
                     </a:solidFill>
                   </a:tcPr>
                 </a:tc>
+                <a:extLst>
+                  <a:ext uri="{0D108BD9-81ED-4DB2-BD59-A6C34878D82A}">
+                    <a16:rowId xmlns:a16="http://schemas.microsoft.com/office/drawing/2014/main" val="10002"/>
+                  </a:ext>
+                </a:extLst>
               </a:tr>
               <a:tr h="685800">
                 <a:tc>
@@ -5943,6 +5930,11 @@
                     </a:solidFill>
                   </a:tcPr>
                 </a:tc>
+                <a:extLst>
+                  <a:ext uri="{0D108BD9-81ED-4DB2-BD59-A6C34878D82A}">
+                    <a16:rowId xmlns:a16="http://schemas.microsoft.com/office/drawing/2014/main" val="10003"/>
+                  </a:ext>
+                </a:extLst>
               </a:tr>
             </a:tbl>
           </a:graphicData>
@@ -5957,7 +5949,7 @@
 </file>
 
 <file path=ppt/slides/slide4.xml><?xml version="1.0" encoding="utf-8"?>
-<p:sld xmlns:a="http://schemas.openxmlformats.org/drawingml/2006/main" xmlns:p="http://schemas.openxmlformats.org/presentationml/2006/main" xmlns:r="http://schemas.openxmlformats.org/officeDocument/2006/relationships">
+<p:sld xmlns:a="http://schemas.openxmlformats.org/drawingml/2006/main" xmlns:r="http://schemas.openxmlformats.org/officeDocument/2006/relationships" xmlns:p="http://schemas.openxmlformats.org/presentationml/2006/main">
   <p:cSld>
     <p:spTree>
       <p:nvGrpSpPr>
@@ -5965,7 +5957,14 @@
         <p:cNvGrpSpPr/>
         <p:nvPr/>
       </p:nvGrpSpPr>
-      <p:grpSpPr/>
+      <p:grpSpPr>
+        <a:xfrm>
+          <a:off x="0" y="0"/>
+          <a:ext cx="0" cy="0"/>
+          <a:chOff x="0" y="0"/>
+          <a:chExt cx="0" cy="0"/>
+        </a:xfrm>
+      </p:grpSpPr>
       <p:sp>
         <p:nvSpPr>
           <p:cNvPr id="2" name="TextBox 1"/>
@@ -6225,7 +6224,7 @@
 </file>
 
 <file path=ppt/slides/slide5.xml><?xml version="1.0" encoding="utf-8"?>
-<p:sld xmlns:a="http://schemas.openxmlformats.org/drawingml/2006/main" xmlns:p="http://schemas.openxmlformats.org/presentationml/2006/main" xmlns:r="http://schemas.openxmlformats.org/officeDocument/2006/relationships">
+<p:sld xmlns:a="http://schemas.openxmlformats.org/drawingml/2006/main" xmlns:r="http://schemas.openxmlformats.org/officeDocument/2006/relationships" xmlns:p="http://schemas.openxmlformats.org/presentationml/2006/main">
   <p:cSld>
     <p:spTree>
       <p:nvGrpSpPr>
@@ -6233,7 +6232,14 @@
         <p:cNvGrpSpPr/>
         <p:nvPr/>
       </p:nvGrpSpPr>
-      <p:grpSpPr/>
+      <p:grpSpPr>
+        <a:xfrm>
+          <a:off x="0" y="0"/>
+          <a:ext cx="0" cy="0"/>
+          <a:chOff x="0" y="0"/>
+          <a:chExt cx="0" cy="0"/>
+        </a:xfrm>
+      </p:grpSpPr>
       <p:sp>
         <p:nvSpPr>
           <p:cNvPr id="2" name="TextBox 1"/>
@@ -6457,7 +6463,7 @@
 </file>
 
 <file path=ppt/slides/slide6.xml><?xml version="1.0" encoding="utf-8"?>
-<p:sld xmlns:a="http://schemas.openxmlformats.org/drawingml/2006/main" xmlns:p="http://schemas.openxmlformats.org/presentationml/2006/main" xmlns:r="http://schemas.openxmlformats.org/officeDocument/2006/relationships">
+<p:sld xmlns:a="http://schemas.openxmlformats.org/drawingml/2006/main" xmlns:r="http://schemas.openxmlformats.org/officeDocument/2006/relationships" xmlns:p="http://schemas.openxmlformats.org/presentationml/2006/main">
   <p:cSld>
     <p:spTree>
       <p:nvGrpSpPr>
@@ -6465,7 +6471,14 @@
         <p:cNvGrpSpPr/>
         <p:nvPr/>
       </p:nvGrpSpPr>
-      <p:grpSpPr/>
+      <p:grpSpPr>
+        <a:xfrm>
+          <a:off x="0" y="0"/>
+          <a:ext cx="0" cy="0"/>
+          <a:chOff x="0" y="0"/>
+          <a:chExt cx="0" cy="0"/>
+        </a:xfrm>
+      </p:grpSpPr>
       <p:sp>
         <p:nvSpPr>
           <p:cNvPr id="2" name="TextBox 1"/>
@@ -6590,13 +6603,31 @@
         <a:graphic>
           <a:graphicData uri="http://schemas.openxmlformats.org/drawingml/2006/table">
             <a:tbl>
-              <a:tblPr firstRow="0" bandRow="0" firstCol="0" bandCol="0" lastRow="0" lastCol="0">
+              <a:tblPr>
                 <a:tableStyleId>{5C22544A-7EE6-4342-B048-85BDC9FD1C3A}</a:tableStyleId>
               </a:tblPr>
               <a:tblGrid>
-                <a:gridCol w="3672840"/>
-                <a:gridCol w="3672840"/>
-                <a:gridCol w="3672840"/>
+                <a:gridCol w="3672840">
+                  <a:extLst>
+                    <a:ext uri="{9D8B030D-6E8A-4147-A177-3AD203B41FA5}">
+                      <a16:colId xmlns:a16="http://schemas.microsoft.com/office/drawing/2014/main" val="20000"/>
+                    </a:ext>
+                  </a:extLst>
+                </a:gridCol>
+                <a:gridCol w="3672840">
+                  <a:extLst>
+                    <a:ext uri="{9D8B030D-6E8A-4147-A177-3AD203B41FA5}">
+                      <a16:colId xmlns:a16="http://schemas.microsoft.com/office/drawing/2014/main" val="20001"/>
+                    </a:ext>
+                  </a:extLst>
+                </a:gridCol>
+                <a:gridCol w="3672840">
+                  <a:extLst>
+                    <a:ext uri="{9D8B030D-6E8A-4147-A177-3AD203B41FA5}">
+                      <a16:colId xmlns:a16="http://schemas.microsoft.com/office/drawing/2014/main" val="20002"/>
+                    </a:ext>
+                  </a:extLst>
+                </a:gridCol>
               </a:tblGrid>
               <a:tr h="594360">
                 <a:tc>
@@ -6665,6 +6696,11 @@
                     </a:solidFill>
                   </a:tcPr>
                 </a:tc>
+                <a:extLst>
+                  <a:ext uri="{0D108BD9-81ED-4DB2-BD59-A6C34878D82A}">
+                    <a16:rowId xmlns:a16="http://schemas.microsoft.com/office/drawing/2014/main" val="10000"/>
+                  </a:ext>
+                </a:extLst>
               </a:tr>
               <a:tr h="594360">
                 <a:tc>
@@ -6733,6 +6769,11 @@
                     </a:solidFill>
                   </a:tcPr>
                 </a:tc>
+                <a:extLst>
+                  <a:ext uri="{0D108BD9-81ED-4DB2-BD59-A6C34878D82A}">
+                    <a16:rowId xmlns:a16="http://schemas.microsoft.com/office/drawing/2014/main" val="10001"/>
+                  </a:ext>
+                </a:extLst>
               </a:tr>
               <a:tr h="594360">
                 <a:tc>
@@ -6801,6 +6842,11 @@
                     </a:solidFill>
                   </a:tcPr>
                 </a:tc>
+                <a:extLst>
+                  <a:ext uri="{0D108BD9-81ED-4DB2-BD59-A6C34878D82A}">
+                    <a16:rowId xmlns:a16="http://schemas.microsoft.com/office/drawing/2014/main" val="10002"/>
+                  </a:ext>
+                </a:extLst>
               </a:tr>
               <a:tr h="594360">
                 <a:tc>
@@ -6869,6 +6915,11 @@
                     </a:solidFill>
                   </a:tcPr>
                 </a:tc>
+                <a:extLst>
+                  <a:ext uri="{0D108BD9-81ED-4DB2-BD59-A6C34878D82A}">
+                    <a16:rowId xmlns:a16="http://schemas.microsoft.com/office/drawing/2014/main" val="10003"/>
+                  </a:ext>
+                </a:extLst>
               </a:tr>
             </a:tbl>
           </a:graphicData>
@@ -6918,7 +6969,7 @@
 </file>
 
 <file path=ppt/slides/slide7.xml><?xml version="1.0" encoding="utf-8"?>
-<p:sld xmlns:a="http://schemas.openxmlformats.org/drawingml/2006/main" xmlns:p="http://schemas.openxmlformats.org/presentationml/2006/main" xmlns:r="http://schemas.openxmlformats.org/officeDocument/2006/relationships">
+<p:sld xmlns:a="http://schemas.openxmlformats.org/drawingml/2006/main" xmlns:r="http://schemas.openxmlformats.org/officeDocument/2006/relationships" xmlns:p="http://schemas.openxmlformats.org/presentationml/2006/main">
   <p:cSld>
     <p:spTree>
       <p:nvGrpSpPr>
@@ -6926,7 +6977,14 @@
         <p:cNvGrpSpPr/>
         <p:nvPr/>
       </p:nvGrpSpPr>
-      <p:grpSpPr/>
+      <p:grpSpPr>
+        <a:xfrm>
+          <a:off x="0" y="0"/>
+          <a:ext cx="0" cy="0"/>
+          <a:chOff x="0" y="0"/>
+          <a:chExt cx="0" cy="0"/>
+        </a:xfrm>
+      </p:grpSpPr>
       <p:sp>
         <p:nvSpPr>
           <p:cNvPr id="2" name="TextBox 1"/>
@@ -7069,7 +7127,7 @@
 </file>
 
 <file path=ppt/slides/slide8.xml><?xml version="1.0" encoding="utf-8"?>
-<p:sld xmlns:a="http://schemas.openxmlformats.org/drawingml/2006/main" xmlns:p="http://schemas.openxmlformats.org/presentationml/2006/main" xmlns:r="http://schemas.openxmlformats.org/officeDocument/2006/relationships">
+<p:sld xmlns:a="http://schemas.openxmlformats.org/drawingml/2006/main" xmlns:r="http://schemas.openxmlformats.org/officeDocument/2006/relationships" xmlns:p="http://schemas.openxmlformats.org/presentationml/2006/main">
   <p:cSld>
     <p:spTree>
       <p:nvGrpSpPr>
@@ -7077,7 +7135,14 @@
         <p:cNvGrpSpPr/>
         <p:nvPr/>
       </p:nvGrpSpPr>
-      <p:grpSpPr/>
+      <p:grpSpPr>
+        <a:xfrm>
+          <a:off x="0" y="0"/>
+          <a:ext cx="0" cy="0"/>
+          <a:chOff x="0" y="0"/>
+          <a:chExt cx="0" cy="0"/>
+        </a:xfrm>
+      </p:grpSpPr>
       <p:sp>
         <p:nvSpPr>
           <p:cNvPr id="2" name="TextBox 1"/>
@@ -7161,7 +7226,7 @@
 </file>
 
 <file path=ppt/theme/theme1.xml><?xml version="1.0" encoding="utf-8"?>
-<a:theme xmlns:a="http://schemas.openxmlformats.org/drawingml/2006/main" xmlns:r="http://schemas.openxmlformats.org/officeDocument/2006/relationships" xmlns:p="http://schemas.openxmlformats.org/presentationml/2006/main" name="Banded Design Blue 16x9">
+<a:theme xmlns:a="http://schemas.openxmlformats.org/drawingml/2006/main" name="Banded Design Blue 16x9">
   <a:themeElements>
     <a:clrScheme name="Banded_Design_Blue">
       <a:dk1>
@@ -7353,11 +7418,12 @@
     </a:fmtScheme>
   </a:themeElements>
   <a:objectDefaults/>
+  <a:extraClrSchemeLst/>
 </a:theme>
 </file>
 
 <file path=ppt/theme/theme2.xml><?xml version="1.0" encoding="utf-8"?>
-<a:theme xmlns:a="http://schemas.openxmlformats.org/drawingml/2006/main" xmlns:r="http://schemas.openxmlformats.org/officeDocument/2006/relationships" xmlns:p="http://schemas.openxmlformats.org/presentationml/2006/main" name="Office Theme">
+<a:theme xmlns:a="http://schemas.openxmlformats.org/drawingml/2006/main" name="Office Theme">
   <a:themeElements>
     <a:clrScheme name="Banded_Design_Teal">
       <a:dk1>
@@ -7555,5 +7621,6 @@
     </a:fmtScheme>
   </a:themeElements>
   <a:objectDefaults/>
+  <a:extraClrSchemeLst/>
 </a:theme>
 </file>
</xml_diff>

<commit_message>
docs(ppt): put the figure spec inside the template, not only in the doc
§7 이 문서에만 있어서 그림이 실제로 어떻게 생겨야 하는지 파일에서 볼 수가
없었다. 회색 "[시각물 영역]" 자리표시자로는 크기도 배율도 전달되지 않는다.

- 4번 슬라이드(P2)에 규격대로 뽑은 실물 그림을 300dpi 원본 크기(7.05 in,
  배율 100%)로 삽입. 배율을 건드리면 안 된다는 규칙이 예시로 드러난다.
- 9번에 그림 규격 참고 카드 추가 (발표 전 삭제하는 장).
- bbox_inches="tight" 가 여백을 잘라 실제 크기가 figsize 보다 작다는 점을
  §7 에 명시 (7.4 -> 7.05 in).

Co-Authored-By: Claude Opus 4.8 <noreply@anthropic.com>
Claude-Session: https://claude.ai/code/session_01FfKQPAstkv5E1GtvR5op9j
</commit_message>
<xml_diff>
--- a/ppt/template/radp-progress-template.pptx
+++ b/ppt/template/radp-progress-template.pptx
@@ -16,6 +16,7 @@
     <p:sldId id="261" r:id="rId7"/>
     <p:sldId id="262" r:id="rId8"/>
     <p:sldId id="263" r:id="rId9"/>
+    <p:sldId id="264" r:id="rId15"/>
   </p:sldIdLst>
   <p:sldSz cx="12192000" cy="6858000"/>
   <p:notesSz cx="6802438" cy="9934575"/>
@@ -6135,53 +6136,6 @@
       </p:sp>
       <p:sp>
         <p:nvSpPr>
-          <p:cNvPr id="6" name="TextBox 5"/>
-          <p:cNvSpPr txBox="1"/>
-          <p:nvPr/>
-        </p:nvSpPr>
-        <p:spPr>
-          <a:xfrm>
-            <a:off x="4846320" y="1600200"/>
-            <a:ext cx="6766560" cy="4069080"/>
-          </a:xfrm>
-          <a:prstGeom prst="rect">
-            <a:avLst/>
-          </a:prstGeom>
-          <a:noFill/>
-        </p:spPr>
-        <p:txBody>
-          <a:bodyPr wrap="square">
-            <a:spAutoFit/>
-          </a:bodyPr>
-          <a:lstStyle/>
-          <a:p>
-            <a:pPr algn="ctr"/>
-            <a:r>
-              <a:rPr sz="1600" b="0">
-                <a:solidFill>
-                  <a:srgbClr val="0070C0"/>
-                </a:solidFill>
-                <a:latin typeface="Roboto"/>
-              </a:rPr>
-              <a:t>[ 시각물 영역 ]</a:t>
-            </a:r>
-          </a:p>
-          <a:p>
-            <a:pPr algn="ctr"/>
-            <a:r>
-              <a:rPr sz="1600" b="0">
-                <a:solidFill>
-                  <a:srgbClr val="0070C0"/>
-                </a:solidFill>
-                <a:latin typeface="Roboto"/>
-              </a:rPr>
-              <a:t>7.4 × 4.45 in</a:t>
-            </a:r>
-          </a:p>
-        </p:txBody>
-      </p:sp>
-      <p:sp>
-        <p:nvSpPr>
           <p:cNvPr id="7" name="TextBox 6"/>
           <p:cNvSpPr txBox="1"/>
           <p:nvPr/>
@@ -6215,6 +6169,30 @@
           </a:p>
         </p:txBody>
       </p:sp>
+      <p:pic>
+        <p:nvPicPr>
+          <p:cNvPr id="8" name="Picture 7" descr="fig_recovery_ttr_slide.png"/>
+          <p:cNvPicPr>
+            <a:picLocks noChangeAspect="1"/>
+          </p:cNvPicPr>
+          <p:nvPr/>
+        </p:nvPicPr>
+        <p:blipFill>
+          <a:blip r:embed="rId2"/>
+          <a:stretch>
+            <a:fillRect/>
+          </a:stretch>
+        </p:blipFill>
+        <p:spPr>
+          <a:xfrm>
+            <a:off x="4846320" y="1600200"/>
+            <a:ext cx="6446520" cy="3872791"/>
+          </a:xfrm>
+          <a:prstGeom prst="rect">
+            <a:avLst/>
+          </a:prstGeom>
+        </p:spPr>
+      </p:pic>
     </p:spTree>
   </p:cSld>
   <p:clrMapOvr>
@@ -7213,6 +7191,927 @@
                 <a:latin typeface="Roboto"/>
               </a:rPr>
               <a:t>[1] Author, "Title," Venue, Year.</a:t>
+            </a:r>
+          </a:p>
+        </p:txBody>
+      </p:sp>
+    </p:spTree>
+  </p:cSld>
+  <p:clrMapOvr>
+    <a:masterClrMapping/>
+  </p:clrMapOvr>
+</p:sld>
+</file>
+
+<file path=ppt/slides/slide9.xml><?xml version="1.0" encoding="utf-8"?>
+<p:sld xmlns:a="http://schemas.openxmlformats.org/drawingml/2006/main" xmlns:p="http://schemas.openxmlformats.org/presentationml/2006/main" xmlns:r="http://schemas.openxmlformats.org/officeDocument/2006/relationships">
+  <p:cSld>
+    <p:spTree>
+      <p:nvGrpSpPr>
+        <p:cNvPr id="1" name=""/>
+        <p:cNvGrpSpPr/>
+        <p:nvPr/>
+      </p:nvGrpSpPr>
+      <p:grpSpPr/>
+      <p:sp>
+        <p:nvSpPr>
+          <p:cNvPr id="2" name="TextBox 1"/>
+          <p:cNvSpPr txBox="1"/>
+          <p:nvPr/>
+        </p:nvSpPr>
+        <p:spPr>
+          <a:xfrm>
+            <a:off x="0" y="0"/>
+            <a:ext cx="12188952" cy="475488"/>
+          </a:xfrm>
+          <a:prstGeom prst="rect">
+            <a:avLst/>
+          </a:prstGeom>
+          <a:solidFill>
+            <a:srgbClr val="202843"/>
+          </a:solidFill>
+          <a:ln>
+            <a:noFill/>
+          </a:ln>
+        </p:spPr>
+        <p:txBody>
+          <a:bodyPr wrap="none" lIns="164592" tIns="18288">
+            <a:spAutoFit/>
+          </a:bodyPr>
+          <a:lstStyle/>
+          <a:p>
+            <a:r>
+              <a:rPr sz="2800">
+                <a:solidFill>
+                  <a:srgbClr val="FFFFFF"/>
+                </a:solidFill>
+                <a:latin typeface="Roboto"/>
+              </a:rPr>
+              <a:t>그림 규격 (참고용 — 발표 전 이 장은 삭제)</a:t>
+            </a:r>
+          </a:p>
+        </p:txBody>
+      </p:sp>
+      <p:sp>
+        <p:nvSpPr>
+          <p:cNvPr id="3" name="TextBox 2"/>
+          <p:cNvSpPr txBox="1"/>
+          <p:nvPr/>
+        </p:nvSpPr>
+        <p:spPr>
+          <a:xfrm>
+            <a:off x="576072" y="685800"/>
+            <a:ext cx="11018520" cy="365760"/>
+          </a:xfrm>
+          <a:prstGeom prst="rect">
+            <a:avLst/>
+          </a:prstGeom>
+          <a:noFill/>
+        </p:spPr>
+        <p:txBody>
+          <a:bodyPr wrap="square">
+            <a:spAutoFit/>
+          </a:bodyPr>
+          <a:lstStyle/>
+          <a:p>
+            <a:pPr algn="l" marL="0" indent="0">
+              <a:buNone/>
+            </a:pPr>
+            <a:r>
+              <a:rPr sz="1600" b="1">
+                <a:solidFill>
+                  <a:srgbClr val="0070C0"/>
+                </a:solidFill>
+                <a:latin typeface="Roboto"/>
+              </a:rPr>
+              <a:t>그림은 PowerPoint 에서 만들지 않는다. paper/figures/_slide.py 로 뽑아서 배율 100% 로 얹는다.</a:t>
+            </a:r>
+          </a:p>
+        </p:txBody>
+      </p:sp>
+      <p:graphicFrame>
+        <p:nvGraphicFramePr>
+          <p:cNvPr id="4" name="Table 3"/>
+          <p:cNvGraphicFramePr>
+            <a:graphicFrameLocks noGrp="1"/>
+          </p:cNvGraphicFramePr>
+          <p:nvPr/>
+        </p:nvGraphicFramePr>
+        <p:xfrm>
+          <a:off x="576072" y="1234440"/>
+          <a:ext cx="6400800" cy="3291840"/>
+        </p:xfrm>
+        <a:graphic>
+          <a:graphicData uri="http://schemas.openxmlformats.org/drawingml/2006/table">
+            <a:tbl>
+              <a:tblPr firstRow="0" bandRow="0" firstCol="0" bandCol="0" lastRow="0" lastCol="0">
+                <a:tableStyleId>{5C22544A-7EE6-4342-B048-85BDC9FD1C3A}</a:tableStyleId>
+              </a:tblPr>
+              <a:tblGrid>
+                <a:gridCol w="1737360"/>
+                <a:gridCol w="1554480"/>
+                <a:gridCol w="3108960"/>
+              </a:tblGrid>
+              <a:tr h="470262">
+                <a:tc>
+                  <a:txBody>
+                    <a:bodyPr/>
+                    <a:lstStyle/>
+                    <a:p>
+                      <a:r>
+                        <a:rPr sz="1300" b="1">
+                          <a:solidFill>
+                            <a:srgbClr val="FFFFFF"/>
+                          </a:solidFill>
+                          <a:latin typeface="Roboto"/>
+                        </a:rPr>
+                        <a:t>항목</a:t>
+                      </a:r>
+                    </a:p>
+                  </a:txBody>
+                  <a:tcPr>
+                    <a:solidFill>
+                      <a:srgbClr val="202843"/>
+                    </a:solidFill>
+                  </a:tcPr>
+                </a:tc>
+                <a:tc>
+                  <a:txBody>
+                    <a:bodyPr/>
+                    <a:lstStyle/>
+                    <a:p>
+                      <a:r>
+                        <a:rPr sz="1300" b="1">
+                          <a:solidFill>
+                            <a:srgbClr val="FFFFFF"/>
+                          </a:solidFill>
+                          <a:latin typeface="Roboto"/>
+                        </a:rPr>
+                        <a:t>값</a:t>
+                      </a:r>
+                    </a:p>
+                  </a:txBody>
+                  <a:tcPr>
+                    <a:solidFill>
+                      <a:srgbClr val="202843"/>
+                    </a:solidFill>
+                  </a:tcPr>
+                </a:tc>
+                <a:tc>
+                  <a:txBody>
+                    <a:bodyPr/>
+                    <a:lstStyle/>
+                    <a:p>
+                      <a:r>
+                        <a:rPr sz="1300" b="1">
+                          <a:solidFill>
+                            <a:srgbClr val="FFFFFF"/>
+                          </a:solidFill>
+                          <a:latin typeface="Roboto"/>
+                        </a:rPr>
+                        <a:t>이유</a:t>
+                      </a:r>
+                    </a:p>
+                  </a:txBody>
+                  <a:tcPr>
+                    <a:solidFill>
+                      <a:srgbClr val="202843"/>
+                    </a:solidFill>
+                  </a:tcPr>
+                </a:tc>
+              </a:tr>
+              <a:tr h="470262">
+                <a:tc>
+                  <a:txBody>
+                    <a:bodyPr/>
+                    <a:lstStyle/>
+                    <a:p>
+                      <a:r>
+                        <a:rPr sz="1300" b="0">
+                          <a:solidFill>
+                            <a:srgbClr val="404040"/>
+                          </a:solidFill>
+                          <a:latin typeface="Roboto"/>
+                        </a:rPr>
+                        <a:t>figsize</a:t>
+                      </a:r>
+                    </a:p>
+                  </a:txBody>
+                  <a:tcPr>
+                    <a:solidFill>
+                      <a:srgbClr val="E8EAF0"/>
+                    </a:solidFill>
+                  </a:tcPr>
+                </a:tc>
+                <a:tc>
+                  <a:txBody>
+                    <a:bodyPr/>
+                    <a:lstStyle/>
+                    <a:p>
+                      <a:r>
+                        <a:rPr sz="1300" b="0">
+                          <a:solidFill>
+                            <a:srgbClr val="404040"/>
+                          </a:solidFill>
+                          <a:latin typeface="Roboto"/>
+                        </a:rPr>
+                        <a:t>슬라이드에 놓일 크기 그대로</a:t>
+                      </a:r>
+                    </a:p>
+                  </a:txBody>
+                  <a:tcPr>
+                    <a:solidFill>
+                      <a:srgbClr val="E8EAF0"/>
+                    </a:solidFill>
+                  </a:tcPr>
+                </a:tc>
+                <a:tc>
+                  <a:txBody>
+                    <a:bodyPr/>
+                    <a:lstStyle/>
+                    <a:p>
+                      <a:r>
+                        <a:rPr sz="1300" b="0">
+                          <a:solidFill>
+                            <a:srgbClr val="404040"/>
+                          </a:solidFill>
+                          <a:latin typeface="Roboto"/>
+                        </a:rPr>
+                        <a:t>확대하면 글자만 커진다</a:t>
+                      </a:r>
+                    </a:p>
+                  </a:txBody>
+                  <a:tcPr>
+                    <a:solidFill>
+                      <a:srgbClr val="E8EAF0"/>
+                    </a:solidFill>
+                  </a:tcPr>
+                </a:tc>
+              </a:tr>
+              <a:tr h="470262">
+                <a:tc>
+                  <a:txBody>
+                    <a:bodyPr/>
+                    <a:lstStyle/>
+                    <a:p>
+                      <a:r>
+                        <a:rPr sz="1300" b="0">
+                          <a:solidFill>
+                            <a:srgbClr val="404040"/>
+                          </a:solidFill>
+                          <a:latin typeface="Roboto"/>
+                        </a:rPr>
+                        <a:t>축 라벨 / 눈금</a:t>
+                      </a:r>
+                    </a:p>
+                  </a:txBody>
+                  <a:tcPr>
+                    <a:solidFill>
+                      <a:srgbClr val="F6F7F9"/>
+                    </a:solidFill>
+                  </a:tcPr>
+                </a:tc>
+                <a:tc>
+                  <a:txBody>
+                    <a:bodyPr/>
+                    <a:lstStyle/>
+                    <a:p>
+                      <a:r>
+                        <a:rPr sz="1300" b="0">
+                          <a:solidFill>
+                            <a:srgbClr val="404040"/>
+                          </a:solidFill>
+                          <a:latin typeface="Roboto"/>
+                        </a:rPr>
+                        <a:t>14pt / 12pt</a:t>
+                      </a:r>
+                    </a:p>
+                  </a:txBody>
+                  <a:tcPr>
+                    <a:solidFill>
+                      <a:srgbClr val="F6F7F9"/>
+                    </a:solidFill>
+                  </a:tcPr>
+                </a:tc>
+                <a:tc>
+                  <a:txBody>
+                    <a:bodyPr/>
+                    <a:lstStyle/>
+                    <a:p>
+                      <a:r>
+                        <a:rPr sz="1300" b="0">
+                          <a:solidFill>
+                            <a:srgbClr val="404040"/>
+                          </a:solidFill>
+                          <a:latin typeface="Roboto"/>
+                        </a:rPr>
+                        <a:t>논문용 8pt 는 안 보인다</a:t>
+                      </a:r>
+                    </a:p>
+                  </a:txBody>
+                  <a:tcPr>
+                    <a:solidFill>
+                      <a:srgbClr val="F6F7F9"/>
+                    </a:solidFill>
+                  </a:tcPr>
+                </a:tc>
+              </a:tr>
+              <a:tr h="470262">
+                <a:tc>
+                  <a:txBody>
+                    <a:bodyPr/>
+                    <a:lstStyle/>
+                    <a:p>
+                      <a:r>
+                        <a:rPr sz="1300" b="0">
+                          <a:solidFill>
+                            <a:srgbClr val="404040"/>
+                          </a:solidFill>
+                          <a:latin typeface="Roboto"/>
+                        </a:rPr>
+                        <a:t>범례 / 주석</a:t>
+                      </a:r>
+                    </a:p>
+                  </a:txBody>
+                  <a:tcPr>
+                    <a:solidFill>
+                      <a:srgbClr val="E8EAF0"/>
+                    </a:solidFill>
+                  </a:tcPr>
+                </a:tc>
+                <a:tc>
+                  <a:txBody>
+                    <a:bodyPr/>
+                    <a:lstStyle/>
+                    <a:p>
+                      <a:r>
+                        <a:rPr sz="1300" b="0">
+                          <a:solidFill>
+                            <a:srgbClr val="404040"/>
+                          </a:solidFill>
+                          <a:latin typeface="Roboto"/>
+                        </a:rPr>
+                        <a:t>12pt / 13pt</a:t>
+                      </a:r>
+                    </a:p>
+                  </a:txBody>
+                  <a:tcPr>
+                    <a:solidFill>
+                      <a:srgbClr val="E8EAF0"/>
+                    </a:solidFill>
+                  </a:tcPr>
+                </a:tc>
+                <a:tc>
+                  <a:txBody>
+                    <a:bodyPr/>
+                    <a:lstStyle/>
+                    <a:p>
+                      <a:r>
+                        <a:rPr sz="1300" b="0">
+                          <a:solidFill>
+                            <a:srgbClr val="404040"/>
+                          </a:solidFill>
+                          <a:latin typeface="Roboto"/>
+                        </a:rPr>
+                        <a:t>축 안에 넣어 여백을 아낀다</a:t>
+                      </a:r>
+                    </a:p>
+                  </a:txBody>
+                  <a:tcPr>
+                    <a:solidFill>
+                      <a:srgbClr val="E8EAF0"/>
+                    </a:solidFill>
+                  </a:tcPr>
+                </a:tc>
+              </a:tr>
+              <a:tr h="470262">
+                <a:tc>
+                  <a:txBody>
+                    <a:bodyPr/>
+                    <a:lstStyle/>
+                    <a:p>
+                      <a:r>
+                        <a:rPr sz="1300" b="0">
+                          <a:solidFill>
+                            <a:srgbClr val="404040"/>
+                          </a:solidFill>
+                          <a:latin typeface="Roboto"/>
+                        </a:rPr>
+                        <a:t>선 두께</a:t>
+                      </a:r>
+                    </a:p>
+                  </a:txBody>
+                  <a:tcPr>
+                    <a:solidFill>
+                      <a:srgbClr val="F6F7F9"/>
+                    </a:solidFill>
+                  </a:tcPr>
+                </a:tc>
+                <a:tc>
+                  <a:txBody>
+                    <a:bodyPr/>
+                    <a:lstStyle/>
+                    <a:p>
+                      <a:r>
+                        <a:rPr sz="1300" b="0">
+                          <a:solidFill>
+                            <a:srgbClr val="404040"/>
+                          </a:solidFill>
+                          <a:latin typeface="Roboto"/>
+                        </a:rPr>
+                        <a:t>2.0</a:t>
+                      </a:r>
+                    </a:p>
+                  </a:txBody>
+                  <a:tcPr>
+                    <a:solidFill>
+                      <a:srgbClr val="F6F7F9"/>
+                    </a:solidFill>
+                  </a:tcPr>
+                </a:tc>
+                <a:tc>
+                  <a:txBody>
+                    <a:bodyPr/>
+                    <a:lstStyle/>
+                    <a:p>
+                      <a:r>
+                        <a:rPr sz="1300" b="0">
+                          <a:solidFill>
+                            <a:srgbClr val="404040"/>
+                          </a:solidFill>
+                          <a:latin typeface="Roboto"/>
+                        </a:rPr>
+                        <a:t>프로젝터에서 얇은 선은 사라진다</a:t>
+                      </a:r>
+                    </a:p>
+                  </a:txBody>
+                  <a:tcPr>
+                    <a:solidFill>
+                      <a:srgbClr val="F6F7F9"/>
+                    </a:solidFill>
+                  </a:tcPr>
+                </a:tc>
+              </a:tr>
+              <a:tr h="470262">
+                <a:tc>
+                  <a:txBody>
+                    <a:bodyPr/>
+                    <a:lstStyle/>
+                    <a:p>
+                      <a:r>
+                        <a:rPr sz="1300" b="0">
+                          <a:solidFill>
+                            <a:srgbClr val="404040"/>
+                          </a:solidFill>
+                          <a:latin typeface="Roboto"/>
+                        </a:rPr>
+                        <a:t>dpi</a:t>
+                      </a:r>
+                    </a:p>
+                  </a:txBody>
+                  <a:tcPr>
+                    <a:solidFill>
+                      <a:srgbClr val="E8EAF0"/>
+                    </a:solidFill>
+                  </a:tcPr>
+                </a:tc>
+                <a:tc>
+                  <a:txBody>
+                    <a:bodyPr/>
+                    <a:lstStyle/>
+                    <a:p>
+                      <a:r>
+                        <a:rPr sz="1300" b="0">
+                          <a:solidFill>
+                            <a:srgbClr val="404040"/>
+                          </a:solidFill>
+                          <a:latin typeface="Roboto"/>
+                        </a:rPr>
+                        <a:t>300, png + pdf</a:t>
+                      </a:r>
+                    </a:p>
+                  </a:txBody>
+                  <a:tcPr>
+                    <a:solidFill>
+                      <a:srgbClr val="E8EAF0"/>
+                    </a:solidFill>
+                  </a:tcPr>
+                </a:tc>
+                <a:tc>
+                  <a:txBody>
+                    <a:bodyPr/>
+                    <a:lstStyle/>
+                    <a:p>
+                      <a:r>
+                        <a:rPr sz="1300" b="0">
+                          <a:solidFill>
+                            <a:srgbClr val="404040"/>
+                          </a:solidFill>
+                          <a:latin typeface="Roboto"/>
+                        </a:rPr>
+                        <a:t>pdf 는 논문에 재사용</a:t>
+                      </a:r>
+                    </a:p>
+                  </a:txBody>
+                  <a:tcPr>
+                    <a:solidFill>
+                      <a:srgbClr val="E8EAF0"/>
+                    </a:solidFill>
+                  </a:tcPr>
+                </a:tc>
+              </a:tr>
+              <a:tr h="470268">
+                <a:tc>
+                  <a:txBody>
+                    <a:bodyPr/>
+                    <a:lstStyle/>
+                    <a:p>
+                      <a:r>
+                        <a:rPr sz="1300" b="0">
+                          <a:solidFill>
+                            <a:srgbClr val="404040"/>
+                          </a:solidFill>
+                          <a:latin typeface="Roboto"/>
+                        </a:rPr>
+                        <a:t>배치 배율</a:t>
+                      </a:r>
+                    </a:p>
+                  </a:txBody>
+                  <a:tcPr>
+                    <a:solidFill>
+                      <a:srgbClr val="F6F7F9"/>
+                    </a:solidFill>
+                  </a:tcPr>
+                </a:tc>
+                <a:tc>
+                  <a:txBody>
+                    <a:bodyPr/>
+                    <a:lstStyle/>
+                    <a:p>
+                      <a:r>
+                        <a:rPr sz="1300" b="0">
+                          <a:solidFill>
+                            <a:srgbClr val="404040"/>
+                          </a:solidFill>
+                          <a:latin typeface="Roboto"/>
+                        </a:rPr>
+                        <a:t>100% 고정</a:t>
+                      </a:r>
+                    </a:p>
+                  </a:txBody>
+                  <a:tcPr>
+                    <a:solidFill>
+                      <a:srgbClr val="F6F7F9"/>
+                    </a:solidFill>
+                  </a:tcPr>
+                </a:tc>
+                <a:tc>
+                  <a:txBody>
+                    <a:bodyPr/>
+                    <a:lstStyle/>
+                    <a:p>
+                      <a:r>
+                        <a:rPr sz="1300" b="0">
+                          <a:solidFill>
+                            <a:srgbClr val="404040"/>
+                          </a:solidFill>
+                          <a:latin typeface="Roboto"/>
+                        </a:rPr>
+                        <a:t>늘리는 순간 덱과 글자 크기가 어긋난다</a:t>
+                      </a:r>
+                    </a:p>
+                  </a:txBody>
+                  <a:tcPr>
+                    <a:solidFill>
+                      <a:srgbClr val="F6F7F9"/>
+                    </a:solidFill>
+                  </a:tcPr>
+                </a:tc>
+              </a:tr>
+            </a:tbl>
+          </a:graphicData>
+        </a:graphic>
+      </p:graphicFrame>
+      <p:sp>
+        <p:nvSpPr>
+          <p:cNvPr id="5" name="TextBox 4"/>
+          <p:cNvSpPr txBox="1"/>
+          <p:nvPr/>
+        </p:nvSpPr>
+        <p:spPr>
+          <a:xfrm>
+            <a:off x="7315200" y="1234440"/>
+            <a:ext cx="4297680" cy="320040"/>
+          </a:xfrm>
+          <a:prstGeom prst="rect">
+            <a:avLst/>
+          </a:prstGeom>
+          <a:noFill/>
+        </p:spPr>
+        <p:txBody>
+          <a:bodyPr wrap="square">
+            <a:spAutoFit/>
+          </a:bodyPr>
+          <a:lstStyle/>
+          <a:p>
+            <a:pPr algn="l" marL="0" indent="0">
+              <a:buNone/>
+            </a:pPr>
+            <a:r>
+              <a:rPr sz="1600" b="1">
+                <a:solidFill>
+                  <a:srgbClr val="FF0000"/>
+                </a:solidFill>
+                <a:latin typeface="Roboto"/>
+              </a:rPr>
+              <a:t>그림 안에 넣지 않는다</a:t>
+            </a:r>
+          </a:p>
+        </p:txBody>
+      </p:sp>
+      <p:sp>
+        <p:nvSpPr>
+          <p:cNvPr id="6" name="TextBox 5"/>
+          <p:cNvSpPr txBox="1"/>
+          <p:nvPr/>
+        </p:nvSpPr>
+        <p:spPr>
+          <a:xfrm>
+            <a:off x="7315200" y="1645920"/>
+            <a:ext cx="4297680" cy="1371600"/>
+          </a:xfrm>
+          <a:prstGeom prst="rect">
+            <a:avLst/>
+          </a:prstGeom>
+          <a:noFill/>
+        </p:spPr>
+        <p:txBody>
+          <a:bodyPr wrap="square">
+            <a:spAutoFit/>
+          </a:bodyPr>
+          <a:lstStyle/>
+          <a:p>
+            <a:pPr algn="l" marL="0" indent="0">
+              <a:buNone/>
+            </a:pPr>
+            <a:r>
+              <a:rPr sz="1400" b="0">
+                <a:solidFill>
+                  <a:srgbClr val="404040"/>
+                </a:solidFill>
+                <a:latin typeface="Roboto"/>
+              </a:rPr>
+              <a:t>제목 — 슬라이드 제목이 그 역할을 한다</a:t>
+            </a:r>
+          </a:p>
+          <a:p>
+            <a:pPr algn="l" marL="0" indent="0">
+              <a:buNone/>
+            </a:pPr>
+            <a:r>
+              <a:rPr sz="1400" b="0">
+                <a:solidFill>
+                  <a:srgbClr val="404040"/>
+                </a:solidFill>
+                <a:latin typeface="Roboto"/>
+              </a:rPr>
+              <a:t>축 밖 범례 — 여백을 먹는다</a:t>
+            </a:r>
+          </a:p>
+          <a:p>
+            <a:pPr algn="l" marL="0" indent="0">
+              <a:buNone/>
+            </a:pPr>
+            <a:r>
+              <a:rPr sz="1400" b="0">
+                <a:solidFill>
+                  <a:srgbClr val="404040"/>
+                </a:solidFill>
+                <a:latin typeface="Roboto"/>
+              </a:rPr>
+              <a:t>진한 격자 — alpha 0.3 이하로</a:t>
+            </a:r>
+          </a:p>
+        </p:txBody>
+      </p:sp>
+      <p:sp>
+        <p:nvSpPr>
+          <p:cNvPr id="7" name="TextBox 6"/>
+          <p:cNvSpPr txBox="1"/>
+          <p:nvPr/>
+        </p:nvSpPr>
+        <p:spPr>
+          <a:xfrm>
+            <a:off x="7315200" y="3154680"/>
+            <a:ext cx="4297680" cy="320040"/>
+          </a:xfrm>
+          <a:prstGeom prst="rect">
+            <a:avLst/>
+          </a:prstGeom>
+          <a:noFill/>
+        </p:spPr>
+        <p:txBody>
+          <a:bodyPr wrap="square">
+            <a:spAutoFit/>
+          </a:bodyPr>
+          <a:lstStyle/>
+          <a:p>
+            <a:pPr algn="l" marL="0" indent="0">
+              <a:buNone/>
+            </a:pPr>
+            <a:r>
+              <a:rPr sz="1600" b="1">
+                <a:solidFill>
+                  <a:srgbClr val="0070C0"/>
+                </a:solidFill>
+                <a:latin typeface="Roboto"/>
+              </a:rPr>
+              <a:t>색은 §4 고정 배정을 따른다</a:t>
+            </a:r>
+          </a:p>
+        </p:txBody>
+      </p:sp>
+      <p:sp>
+        <p:nvSpPr>
+          <p:cNvPr id="8" name="TextBox 7"/>
+          <p:cNvSpPr txBox="1"/>
+          <p:nvPr/>
+        </p:nvSpPr>
+        <p:spPr>
+          <a:xfrm>
+            <a:off x="7315200" y="3520440"/>
+            <a:ext cx="4297680" cy="274320"/>
+          </a:xfrm>
+          <a:prstGeom prst="rect">
+            <a:avLst/>
+          </a:prstGeom>
+          <a:noFill/>
+        </p:spPr>
+        <p:txBody>
+          <a:bodyPr wrap="square">
+            <a:spAutoFit/>
+          </a:bodyPr>
+          <a:lstStyle/>
+          <a:p>
+            <a:pPr algn="l" marL="0" indent="0">
+              <a:buNone/>
+            </a:pPr>
+            <a:r>
+              <a:rPr sz="1400" b="1">
+                <a:solidFill>
+                  <a:srgbClr val="FF0000"/>
+                </a:solidFill>
+                <a:latin typeface="Roboto"/>
+              </a:rPr>
+              <a:t>full-replay  FF0000</a:t>
+            </a:r>
+          </a:p>
+        </p:txBody>
+      </p:sp>
+      <p:sp>
+        <p:nvSpPr>
+          <p:cNvPr id="9" name="TextBox 8"/>
+          <p:cNvSpPr txBox="1"/>
+          <p:nvPr/>
+        </p:nvSpPr>
+        <p:spPr>
+          <a:xfrm>
+            <a:off x="7315200" y="3831336"/>
+            <a:ext cx="4297680" cy="274320"/>
+          </a:xfrm>
+          <a:prstGeom prst="rect">
+            <a:avLst/>
+          </a:prstGeom>
+          <a:noFill/>
+        </p:spPr>
+        <p:txBody>
+          <a:bodyPr wrap="square">
+            <a:spAutoFit/>
+          </a:bodyPr>
+          <a:lstStyle/>
+          <a:p>
+            <a:pPr algn="l" marL="0" indent="0">
+              <a:buNone/>
+            </a:pPr>
+            <a:r>
+              <a:rPr sz="1400" b="1">
+                <a:solidFill>
+                  <a:srgbClr val="202843"/>
+                </a:solidFill>
+                <a:latin typeface="Roboto"/>
+              </a:rPr>
+              <a:t>surgical     202843</a:t>
+            </a:r>
+          </a:p>
+        </p:txBody>
+      </p:sp>
+      <p:sp>
+        <p:nvSpPr>
+          <p:cNvPr id="10" name="TextBox 9"/>
+          <p:cNvSpPr txBox="1"/>
+          <p:nvPr/>
+        </p:nvSpPr>
+        <p:spPr>
+          <a:xfrm>
+            <a:off x="7315200" y="4142232"/>
+            <a:ext cx="4297680" cy="274320"/>
+          </a:xfrm>
+          <a:prstGeom prst="rect">
+            <a:avLst/>
+          </a:prstGeom>
+          <a:noFill/>
+        </p:spPr>
+        <p:txBody>
+          <a:bodyPr wrap="square">
+            <a:spAutoFit/>
+          </a:bodyPr>
+          <a:lstStyle/>
+          <a:p>
+            <a:pPr algn="l" marL="0" indent="0">
+              <a:buNone/>
+            </a:pPr>
+            <a:r>
+              <a:rPr sz="1400" b="1">
+                <a:solidFill>
+                  <a:srgbClr val="0070C0"/>
+                </a:solidFill>
+                <a:latin typeface="Roboto"/>
+              </a:rPr>
+              <a:t>parity       0070C0</a:t>
+            </a:r>
+          </a:p>
+        </p:txBody>
+      </p:sp>
+      <p:sp>
+        <p:nvSpPr>
+          <p:cNvPr id="11" name="TextBox 10"/>
+          <p:cNvSpPr txBox="1"/>
+          <p:nvPr/>
+        </p:nvSpPr>
+        <p:spPr>
+          <a:xfrm>
+            <a:off x="576072" y="4709160"/>
+            <a:ext cx="11018520" cy="320040"/>
+          </a:xfrm>
+          <a:prstGeom prst="rect">
+            <a:avLst/>
+          </a:prstGeom>
+          <a:noFill/>
+        </p:spPr>
+        <p:txBody>
+          <a:bodyPr wrap="square">
+            <a:spAutoFit/>
+          </a:bodyPr>
+          <a:lstStyle/>
+          <a:p>
+            <a:pPr algn="l" marL="0" indent="0">
+              <a:buNone/>
+            </a:pPr>
+            <a:r>
+              <a:rPr sz="1600" b="1">
+                <a:solidFill>
+                  <a:srgbClr val="404040"/>
+                </a:solidFill>
+                <a:latin typeface="Roboto"/>
+              </a:rPr>
+              <a:t>캡션: 그림 바로 아래 12pt 한 줄로 환경 / 조건 / 유효 샘플 수</a:t>
+            </a:r>
+          </a:p>
+        </p:txBody>
+      </p:sp>
+      <p:sp>
+        <p:nvSpPr>
+          <p:cNvPr id="12" name="TextBox 11"/>
+          <p:cNvSpPr txBox="1"/>
+          <p:nvPr/>
+        </p:nvSpPr>
+        <p:spPr>
+          <a:xfrm>
+            <a:off x="576072" y="5074920"/>
+            <a:ext cx="11018520" cy="320040"/>
+          </a:xfrm>
+          <a:prstGeom prst="rect">
+            <a:avLst/>
+          </a:prstGeom>
+          <a:noFill/>
+        </p:spPr>
+        <p:txBody>
+          <a:bodyPr wrap="square">
+            <a:spAutoFit/>
+          </a:bodyPr>
+          <a:lstStyle/>
+          <a:p>
+            <a:pPr algn="l" marL="0" indent="0">
+              <a:buNone/>
+            </a:pPr>
+            <a:r>
+              <a:rPr sz="1200" b="0">
+                <a:solidFill>
+                  <a:srgbClr val="404040"/>
+                </a:solidFill>
+                <a:latin typeface="Roboto"/>
+              </a:rPr>
+              <a:t>OPT-350M 24층 / 5-stage 이종 체인 / 15개 트라이얼 전부 유효</a:t>
             </a:r>
           </a:p>
         </p:txBody>

</xml_diff>

<commit_message>
fix(figures): anchor diagram text to shapes, log-scale the TTR chart
설명 텍스트를 데이터 좌표에 손으로 박고 `\n` 으로 직접 줄바꿈해 놔서
도형이 조금만 움직여도 겹치거나 떠 있었다.

- `_slide.py` 에 `panel()` / `note()` 추가. 패널마다 자기 축을 갖고
  제목은 좌/우 title 로 자리를 예약한다. 캡션은 전용 스트립에 놓고
  줄바꿈은 글자 수 기준으로 자동으로 접는다.
- 도형에 딸린 라벨은 `annotate(xy=도형)` 으로 붙여 도형을 따라가게 했다.
  좌표를 외우지 않으므로 배치를 바꿔도 안 어긋난다.
- generalization: 되돌아가는 표식 화살표가 상자 안에서 시작해 hop 과
  겹치던 것을 상자 아래 직선으로 뺐다. slot 개수 라벨을 한 색/한 열로 정렬.
- families: parity 행에만 빨간 테두리가 남아 그 행만 특별해 보이던 것 제거.
  죽은 열은 위쪽 화살표 하나가 세 행 모두를 가리킨다.

TTR 그래프는 축 스케일이 결론을 가리고 있었다. 선형축에서 full-replay 가
6 s 까지 올라가 surgical/parity 가 바닥 5% 에 눌려 붙었다 — 이 그림이
보여주려던 대비가 정작 안 보였다. 로그축으로 셋을 분리하고, 범례 대신
선 끝에 직접 이름을 붙이고, 정상 decode 스텝(163 ms) 기준선을 그어
로그축이 차이를 과장하지 않게 절대 기준을 남겼다.

템플릿 4번 슬라이드의 예시 그림도 새 파일로 교체 (6.42 in, 배율 100%).

Co-Authored-By: Claude Opus 4.8 <noreply@anthropic.com>
Claude-Session: https://claude.ai/code/session_01FfKQPAstkv5E1GtvR5op9j
</commit_message>
<xml_diff>
--- a/ppt/template/radp-progress-template.pptx
+++ b/ppt/template/radp-progress-template.pptx
@@ -6178,7 +6178,7 @@
           <p:nvPr/>
         </p:nvPicPr>
         <p:blipFill>
-          <a:blip r:embed="rId2"/>
+          <a:blip r:embed="rId3"/>
           <a:stretch>
             <a:fillRect/>
           </a:stretch>
@@ -6186,7 +6186,7 @@
         <p:spPr>
           <a:xfrm>
             <a:off x="4846320" y="1600200"/>
-            <a:ext cx="6446520" cy="3872791"/>
+            <a:ext cx="5870448" cy="3895344"/>
           </a:xfrm>
           <a:prstGeom prst="rect">
             <a:avLst/>

</xml_diff>

<commit_message>
docs(ppt): bold subtitles, fix the voice, extract a reusable skill
- 소제목을 **굵게** 로 고정 (§2 해부 / §3 타이포). 템플릿 5장 적용.
- §8 에 「문체」 절 추가. 슬라이드를 서술체로 쓰면 발표자가 읽게 되고,
  읽기 시작하면 청중이 슬라이드를 보지 발표자를 안 본다. 그래서 종결은
  음슴체(-함/-됨/-임) 또는 명사. AI 어투 금지 목록과 "형용사 하나에
  숫자 하나" 규칙을 표로 박았다.
- 체크리스트에 문체·굵기 항목 3개 추가.
- prompt_0721.md 의 슬라이드 문구를 전부 새 문체로 고쳐 씀.

일련의 과정을 ~/.claude/skills/progress-report 로 뽑았다. 규격 문서 +
템플릿 + 슬라이드 스케일 그림 + 주간 프롬프트의 4-artifact 구조,
원본 템플릿에서 규격을 역추출하는 법, 그리고 이번에 실제로 밟은 지뢰
6종(밴드 소실 / 표 밴딩 / 글머리 중복 / 폰트 대체 / 테마색 누출 /
표지 훼손)을 증상-원인 표로 남겼다.

Co-Authored-By: Claude Opus 4.8 <noreply@anthropic.com>
Claude-Session: https://claude.ai/code/session_01FfKQPAstkv5E1GtvR5op9j
</commit_message>
<xml_diff>
--- a/ppt/template/radp-progress-template.pptx
+++ b/ppt/template/radp-progress-template.pptx
@@ -5688,7 +5688,7 @@
           <a:p>
             <a:pPr algn="l"/>
             <a:r>
-              <a:rPr sz="1600" b="0">
+              <a:rPr sz="1600" b="1">
                 <a:solidFill>
                   <a:srgbClr val="404040"/>
                 </a:solidFill>
@@ -6064,7 +6064,7 @@
           <a:p>
             <a:pPr algn="l"/>
             <a:r>
-              <a:rPr sz="1600" b="0">
+              <a:rPr sz="1600" b="1">
                 <a:solidFill>
                   <a:srgbClr val="404040"/>
                 </a:solidFill>
@@ -6316,7 +6316,7 @@
           <a:p>
             <a:pPr algn="l"/>
             <a:r>
-              <a:rPr sz="1600" b="0">
+              <a:rPr sz="1600" b="1">
                 <a:solidFill>
                   <a:srgbClr val="404040"/>
                 </a:solidFill>
@@ -6427,7 +6427,7 @@
                 </a:solidFill>
                 <a:latin typeface="Roboto"/>
               </a:rPr>
-              <a:t>• 두 그림에서 읽어야 할 것</a:t>
+              <a:t>• 두 그림에서 읽어야 할 것 한 줄</a:t>
             </a:r>
           </a:p>
         </p:txBody>
@@ -6555,7 +6555,7 @@
           <a:p>
             <a:pPr algn="l"/>
             <a:r>
-              <a:rPr sz="1600" b="0">
+              <a:rPr sz="1600" b="1">
                 <a:solidFill>
                   <a:srgbClr val="404040"/>
                 </a:solidFill>
@@ -6933,7 +6933,7 @@
                 </a:solidFill>
                 <a:latin typeface="Roboto"/>
               </a:rPr>
-              <a:t>• 표에서 읽어야 할 결론</a:t>
+              <a:t>• 표에서 읽어야 할 것 한 줄</a:t>
             </a:r>
           </a:p>
         </p:txBody>
@@ -7026,7 +7026,7 @@
           <a:p>
             <a:pPr algn="l"/>
             <a:r>
-              <a:rPr sz="1600" b="0">
+              <a:rPr sz="1600" b="1">
                 <a:solidFill>
                   <a:srgbClr val="404040"/>
                 </a:solidFill>
@@ -7067,7 +7067,7 @@
                 </a:solidFill>
                 <a:latin typeface="Roboto"/>
               </a:rPr>
-              <a:t>• 할 일</a:t>
+              <a:t>• 할 일 (명사 종결)</a:t>
             </a:r>
           </a:p>
           <a:p>
@@ -7079,7 +7079,7 @@
                 </a:solidFill>
                 <a:latin typeface="Roboto"/>
               </a:rPr>
-              <a:t>• 할 일</a:t>
+              <a:t>• 할 일 (명사 종결)</a:t>
             </a:r>
           </a:p>
           <a:p>
@@ -7091,7 +7091,7 @@
                 </a:solidFill>
                 <a:latin typeface="Roboto"/>
               </a:rPr>
-              <a:t>• 할 일</a:t>
+              <a:t>• 할 일 (명사 종결)</a:t>
             </a:r>
           </a:p>
         </p:txBody>

</xml_diff>

<commit_message>
docs(ppt): consolidate the type scale into one complete role table
크기는 §3, 표 크기는 §6, 그림 글자는 §7 에 흩어져 있어서 "이 텍스트는
몇 pt 인가" 를 한 곳에서 답할 수 없었다. 실제로 참고 카드가 13/14pt 로
규격 밖에 나가 있었는데 아무 규칙도 그걸 잡지 못했다.

- §3 을 7개 역할 완전표로 통합: 크기 + 굵게 + 색을 한 표에서 읽는다.
  "여기 없는 크기를 새로 만들지 않는다" 를 명시.
- "굵게를 쓰는 자리" 를 소제목 / 표 헤더 / 강조 셀 / 결론 한 줄로 한정.
  굵게가 슬라이드마다 서너 군데 흩어지면 아무 데도 강조가 아니게 된다.
- 참고 카드 27개 run 을 규격 안으로 (표 13->14pt, 본문 14->16pt).
- 체크리스트에 역할 밖 크기 / 굵게 남용 검수 항목 추가.

Co-Authored-By: Claude Opus 4.8 <noreply@anthropic.com>
Claude-Session: https://claude.ai/code/session_01FfKQPAstkv5E1GtvR5op9j
</commit_message>
<xml_diff>
--- a/ppt/template/radp-progress-template.pptx
+++ b/ppt/template/radp-progress-template.pptx
@@ -7319,7 +7319,7 @@
                     <a:lstStyle/>
                     <a:p>
                       <a:r>
-                        <a:rPr sz="1300" b="1">
+                        <a:rPr sz="1400" b="1">
                           <a:solidFill>
                             <a:srgbClr val="FFFFFF"/>
                           </a:solidFill>
@@ -7341,7 +7341,7 @@
                     <a:lstStyle/>
                     <a:p>
                       <a:r>
-                        <a:rPr sz="1300" b="1">
+                        <a:rPr sz="1400" b="1">
                           <a:solidFill>
                             <a:srgbClr val="FFFFFF"/>
                           </a:solidFill>
@@ -7363,7 +7363,7 @@
                     <a:lstStyle/>
                     <a:p>
                       <a:r>
-                        <a:rPr sz="1300" b="1">
+                        <a:rPr sz="1400" b="1">
                           <a:solidFill>
                             <a:srgbClr val="FFFFFF"/>
                           </a:solidFill>
@@ -7387,7 +7387,7 @@
                     <a:lstStyle/>
                     <a:p>
                       <a:r>
-                        <a:rPr sz="1300" b="0">
+                        <a:rPr sz="1400" b="0">
                           <a:solidFill>
                             <a:srgbClr val="404040"/>
                           </a:solidFill>
@@ -7409,7 +7409,7 @@
                     <a:lstStyle/>
                     <a:p>
                       <a:r>
-                        <a:rPr sz="1300" b="0">
+                        <a:rPr sz="1400" b="0">
                           <a:solidFill>
                             <a:srgbClr val="404040"/>
                           </a:solidFill>
@@ -7431,7 +7431,7 @@
                     <a:lstStyle/>
                     <a:p>
                       <a:r>
-                        <a:rPr sz="1300" b="0">
+                        <a:rPr sz="1400" b="0">
                           <a:solidFill>
                             <a:srgbClr val="404040"/>
                           </a:solidFill>
@@ -7455,7 +7455,7 @@
                     <a:lstStyle/>
                     <a:p>
                       <a:r>
-                        <a:rPr sz="1300" b="0">
+                        <a:rPr sz="1400" b="0">
                           <a:solidFill>
                             <a:srgbClr val="404040"/>
                           </a:solidFill>
@@ -7477,7 +7477,7 @@
                     <a:lstStyle/>
                     <a:p>
                       <a:r>
-                        <a:rPr sz="1300" b="0">
+                        <a:rPr sz="1400" b="0">
                           <a:solidFill>
                             <a:srgbClr val="404040"/>
                           </a:solidFill>
@@ -7499,7 +7499,7 @@
                     <a:lstStyle/>
                     <a:p>
                       <a:r>
-                        <a:rPr sz="1300" b="0">
+                        <a:rPr sz="1400" b="0">
                           <a:solidFill>
                             <a:srgbClr val="404040"/>
                           </a:solidFill>
@@ -7523,7 +7523,7 @@
                     <a:lstStyle/>
                     <a:p>
                       <a:r>
-                        <a:rPr sz="1300" b="0">
+                        <a:rPr sz="1400" b="0">
                           <a:solidFill>
                             <a:srgbClr val="404040"/>
                           </a:solidFill>
@@ -7545,7 +7545,7 @@
                     <a:lstStyle/>
                     <a:p>
                       <a:r>
-                        <a:rPr sz="1300" b="0">
+                        <a:rPr sz="1400" b="0">
                           <a:solidFill>
                             <a:srgbClr val="404040"/>
                           </a:solidFill>
@@ -7567,7 +7567,7 @@
                     <a:lstStyle/>
                     <a:p>
                       <a:r>
-                        <a:rPr sz="1300" b="0">
+                        <a:rPr sz="1400" b="0">
                           <a:solidFill>
                             <a:srgbClr val="404040"/>
                           </a:solidFill>
@@ -7591,7 +7591,7 @@
                     <a:lstStyle/>
                     <a:p>
                       <a:r>
-                        <a:rPr sz="1300" b="0">
+                        <a:rPr sz="1400" b="0">
                           <a:solidFill>
                             <a:srgbClr val="404040"/>
                           </a:solidFill>
@@ -7613,7 +7613,7 @@
                     <a:lstStyle/>
                     <a:p>
                       <a:r>
-                        <a:rPr sz="1300" b="0">
+                        <a:rPr sz="1400" b="0">
                           <a:solidFill>
                             <a:srgbClr val="404040"/>
                           </a:solidFill>
@@ -7635,7 +7635,7 @@
                     <a:lstStyle/>
                     <a:p>
                       <a:r>
-                        <a:rPr sz="1300" b="0">
+                        <a:rPr sz="1400" b="0">
                           <a:solidFill>
                             <a:srgbClr val="404040"/>
                           </a:solidFill>
@@ -7659,7 +7659,7 @@
                     <a:lstStyle/>
                     <a:p>
                       <a:r>
-                        <a:rPr sz="1300" b="0">
+                        <a:rPr sz="1400" b="0">
                           <a:solidFill>
                             <a:srgbClr val="404040"/>
                           </a:solidFill>
@@ -7681,7 +7681,7 @@
                     <a:lstStyle/>
                     <a:p>
                       <a:r>
-                        <a:rPr sz="1300" b="0">
+                        <a:rPr sz="1400" b="0">
                           <a:solidFill>
                             <a:srgbClr val="404040"/>
                           </a:solidFill>
@@ -7703,7 +7703,7 @@
                     <a:lstStyle/>
                     <a:p>
                       <a:r>
-                        <a:rPr sz="1300" b="0">
+                        <a:rPr sz="1400" b="0">
                           <a:solidFill>
                             <a:srgbClr val="404040"/>
                           </a:solidFill>
@@ -7727,7 +7727,7 @@
                     <a:lstStyle/>
                     <a:p>
                       <a:r>
-                        <a:rPr sz="1300" b="0">
+                        <a:rPr sz="1400" b="0">
                           <a:solidFill>
                             <a:srgbClr val="404040"/>
                           </a:solidFill>
@@ -7749,7 +7749,7 @@
                     <a:lstStyle/>
                     <a:p>
                       <a:r>
-                        <a:rPr sz="1300" b="0">
+                        <a:rPr sz="1400" b="0">
                           <a:solidFill>
                             <a:srgbClr val="404040"/>
                           </a:solidFill>
@@ -7771,7 +7771,7 @@
                     <a:lstStyle/>
                     <a:p>
                       <a:r>
-                        <a:rPr sz="1300" b="0">
+                        <a:rPr sz="1400" b="0">
                           <a:solidFill>
                             <a:srgbClr val="404040"/>
                           </a:solidFill>
@@ -7855,7 +7855,7 @@
               <a:buNone/>
             </a:pPr>
             <a:r>
-              <a:rPr sz="1400" b="0">
+              <a:rPr sz="1600" b="0">
                 <a:solidFill>
                   <a:srgbClr val="404040"/>
                 </a:solidFill>
@@ -7869,7 +7869,7 @@
               <a:buNone/>
             </a:pPr>
             <a:r>
-              <a:rPr sz="1400" b="0">
+              <a:rPr sz="1600" b="0">
                 <a:solidFill>
                   <a:srgbClr val="404040"/>
                 </a:solidFill>
@@ -7883,7 +7883,7 @@
               <a:buNone/>
             </a:pPr>
             <a:r>
-              <a:rPr sz="1400" b="0">
+              <a:rPr sz="1600" b="0">
                 <a:solidFill>
                   <a:srgbClr val="404040"/>
                 </a:solidFill>
@@ -7957,7 +7957,7 @@
               <a:buNone/>
             </a:pPr>
             <a:r>
-              <a:rPr sz="1400" b="1">
+              <a:rPr sz="1600" b="1">
                 <a:solidFill>
                   <a:srgbClr val="FF0000"/>
                 </a:solidFill>
@@ -7994,7 +7994,7 @@
               <a:buNone/>
             </a:pPr>
             <a:r>
-              <a:rPr sz="1400" b="1">
+              <a:rPr sz="1600" b="1">
                 <a:solidFill>
                   <a:srgbClr val="202843"/>
                 </a:solidFill>
@@ -8031,7 +8031,7 @@
               <a:buNone/>
             </a:pPr>
             <a:r>
-              <a:rPr sz="1400" b="1">
+              <a:rPr sz="1600" b="1">
                 <a:solidFill>
                   <a:srgbClr val="0070C0"/>
                 </a:solidFill>

</xml_diff>